<commit_message>
Add crawl imports and deepen V18-compatible audits
</commit_message>
<xml_diff>
--- a/exports/Kakawa_Chocolates_Enterprise_SEO_Package_v19/00_Executive/Kakawa_Executive_Deck_v19.pptx
+++ b/exports/Kakawa_Chocolates_Enterprise_SEO_Package_v19/00_Executive/Kakawa_Executive_Deck_v19.pptx
@@ -2,21 +2,21 @@
 <file path=ppt/presentation.xml><?xml version="1.0" encoding="utf-8"?>
 <p:presentation xmlns:p="http://schemas.openxmlformats.org/presentationml/2006/main">
   <p:sldMasterIdLst>
-    <p:sldMasterId xmlns:r="http://schemas.openxmlformats.org/officeDocument/2006/relationships" id="2147483648" r:id="Ra03305b32ad34c22"/>
+    <p:sldMasterId xmlns:r="http://schemas.openxmlformats.org/officeDocument/2006/relationships" id="2147483648" r:id="Ra73ab13524524e06"/>
   </p:sldMasterIdLst>
   <p:notesMasterIdLst>
-    <p:notesMasterId xmlns:r="http://schemas.openxmlformats.org/officeDocument/2006/relationships" r:id="Rf0b818c1b0bc4e28"/>
+    <p:notesMasterId xmlns:r="http://schemas.openxmlformats.org/officeDocument/2006/relationships" r:id="Rfd024929538549ee"/>
   </p:notesMasterIdLst>
   <p:sldIdLst>
-    <p:sldId xmlns:r="http://schemas.openxmlformats.org/officeDocument/2006/relationships" id="256" r:id="R9ea0c8f1cd4b4b58"/>
-    <p:sldId xmlns:r="http://schemas.openxmlformats.org/officeDocument/2006/relationships" id="257" r:id="R04bfe433cde94f86"/>
-    <p:sldId xmlns:r="http://schemas.openxmlformats.org/officeDocument/2006/relationships" id="258" r:id="R3e2d4a1785194b3c"/>
-    <p:sldId xmlns:r="http://schemas.openxmlformats.org/officeDocument/2006/relationships" id="259" r:id="Rcaacb80c913a45db"/>
-    <p:sldId xmlns:r="http://schemas.openxmlformats.org/officeDocument/2006/relationships" id="260" r:id="Rea31c9ebee024c77"/>
-    <p:sldId xmlns:r="http://schemas.openxmlformats.org/officeDocument/2006/relationships" id="261" r:id="R62a185da24d84f9a"/>
-    <p:sldId xmlns:r="http://schemas.openxmlformats.org/officeDocument/2006/relationships" id="262" r:id="R4efb5543fde64d04"/>
-    <p:sldId xmlns:r="http://schemas.openxmlformats.org/officeDocument/2006/relationships" id="263" r:id="R3f9410a256124ae4"/>
-    <p:sldId xmlns:r="http://schemas.openxmlformats.org/officeDocument/2006/relationships" id="264" r:id="R584b61dcd8334284"/>
+    <p:sldId xmlns:r="http://schemas.openxmlformats.org/officeDocument/2006/relationships" id="256" r:id="R0b58eb7d66a84525"/>
+    <p:sldId xmlns:r="http://schemas.openxmlformats.org/officeDocument/2006/relationships" id="257" r:id="R0096e47d0cf34530"/>
+    <p:sldId xmlns:r="http://schemas.openxmlformats.org/officeDocument/2006/relationships" id="258" r:id="R06791d93b5d24024"/>
+    <p:sldId xmlns:r="http://schemas.openxmlformats.org/officeDocument/2006/relationships" id="259" r:id="R40397387c6394b3f"/>
+    <p:sldId xmlns:r="http://schemas.openxmlformats.org/officeDocument/2006/relationships" id="260" r:id="R26c2c98d5c8a4daa"/>
+    <p:sldId xmlns:r="http://schemas.openxmlformats.org/officeDocument/2006/relationships" id="261" r:id="Rf41f185aa0054fb9"/>
+    <p:sldId xmlns:r="http://schemas.openxmlformats.org/officeDocument/2006/relationships" id="262" r:id="R4a02c86b4c2c498a"/>
+    <p:sldId xmlns:r="http://schemas.openxmlformats.org/officeDocument/2006/relationships" id="263" r:id="Rb8a89b8310a244c2"/>
+    <p:sldId xmlns:r="http://schemas.openxmlformats.org/officeDocument/2006/relationships" id="264" r:id="R7a09d71f5e964f6a"/>
   </p:sldIdLst>
   <p:sldSz cx="12192000" cy="6858000"/>
   <p:notesSz cx="6858000" cy="9144000"/>
@@ -1137,7 +1137,7 @@
   </p:cSld>
   <p:clrMap bg1="lt1" tx1="dk1" bg2="lt2" tx2="dk2" accent1="accent1" accent2="accent2" accent3="accent3" accent4="accent4" accent5="accent5" accent6="accent6" hlink="hlink" folHlink="folHlink"/>
   <p:sldLayoutIdLst>
-    <p:sldLayoutId xmlns:r="http://schemas.openxmlformats.org/officeDocument/2006/relationships" id="2147483649" r:id="Rf003cd5dd9bc491f"/>
+    <p:sldLayoutId xmlns:r="http://schemas.openxmlformats.org/officeDocument/2006/relationships" id="2147483649" r:id="R245ff69dbc9a4c29"/>
   </p:sldLayoutIdLst>
   <p:txStyles>
     <p:titleStyle>
@@ -1838,7 +1838,7 @@
           <p:cNvPr id="9" name="">
             <a:extLst xmlns:a="http://schemas.openxmlformats.org/drawingml/2006/main">
               <a:ext uri="{FF2B5EF4-FFF2-40B4-BE49-F238E27FC236}">
-                <a16:creationId xmlns:a16="http://schemas.microsoft.com/office/drawing/2014/main" id="{27171D62-C51F-4DE1-8530-52C001A7DB46}"/>
+                <a16:creationId xmlns:a16="http://schemas.microsoft.com/office/drawing/2014/main" id="{B48AC9B2-64E8-43A3-BD9B-AAFDEB7350F7}"/>
               </a:ext>
             </a:extLst>
           </p:cNvPr>
@@ -1869,7 +1869,7 @@
           <p:cNvPr id="2" name="">
             <a:extLst xmlns:a="http://schemas.openxmlformats.org/drawingml/2006/main">
               <a:ext uri="{FF2B5EF4-FFF2-40B4-BE49-F238E27FC236}">
-                <a16:creationId xmlns:a16="http://schemas.microsoft.com/office/drawing/2014/main" id="{DBC41E66-0BBC-408A-99BA-2DE7AB8947AF}"/>
+                <a16:creationId xmlns:a16="http://schemas.microsoft.com/office/drawing/2014/main" id="{37E885C4-FF74-41FD-8770-5D5CBF8715ED}"/>
               </a:ext>
             </a:extLst>
           </p:cNvPr>
@@ -1919,7 +1919,7 @@
           <p:cNvPr id="3" name="">
             <a:extLst xmlns:a="http://schemas.openxmlformats.org/drawingml/2006/main">
               <a:ext uri="{FF2B5EF4-FFF2-40B4-BE49-F238E27FC236}">
-                <a16:creationId xmlns:a16="http://schemas.microsoft.com/office/drawing/2014/main" id="{20D74506-4993-4082-8D4B-A68F7CCB3865}"/>
+                <a16:creationId xmlns:a16="http://schemas.microsoft.com/office/drawing/2014/main" id="{C9C50547-3F1F-4AFB-909A-B64EFB666275}"/>
               </a:ext>
             </a:extLst>
           </p:cNvPr>
@@ -1969,7 +1969,7 @@
           <p:cNvPr id="4" name="">
             <a:extLst xmlns:a="http://schemas.openxmlformats.org/drawingml/2006/main">
               <a:ext uri="{FF2B5EF4-FFF2-40B4-BE49-F238E27FC236}">
-                <a16:creationId xmlns:a16="http://schemas.microsoft.com/office/drawing/2014/main" id="{7C4C5FF3-9F45-4598-AEFE-5E91B388D6AC}"/>
+                <a16:creationId xmlns:a16="http://schemas.microsoft.com/office/drawing/2014/main" id="{C772A549-7017-4543-8081-CD286186A081}"/>
               </a:ext>
             </a:extLst>
           </p:cNvPr>
@@ -2019,7 +2019,7 @@
           <p:cNvPr id="5" name="">
             <a:extLst xmlns:a="http://schemas.openxmlformats.org/drawingml/2006/main">
               <a:ext uri="{FF2B5EF4-FFF2-40B4-BE49-F238E27FC236}">
-                <a16:creationId xmlns:a16="http://schemas.microsoft.com/office/drawing/2014/main" id="{BF728DDA-04E7-4EC4-8A5A-9257FDE12700}"/>
+                <a16:creationId xmlns:a16="http://schemas.microsoft.com/office/drawing/2014/main" id="{0AC952E2-757A-406D-AF55-7352366C70DF}"/>
               </a:ext>
             </a:extLst>
           </p:cNvPr>
@@ -2086,7 +2086,7 @@
           <p:cNvPr id="6" name="">
             <a:extLst xmlns:a="http://schemas.openxmlformats.org/drawingml/2006/main">
               <a:ext uri="{FF2B5EF4-FFF2-40B4-BE49-F238E27FC236}">
-                <a16:creationId xmlns:a16="http://schemas.microsoft.com/office/drawing/2014/main" id="{27705CD4-FA24-4E48-B227-8ACB02245FD6}"/>
+                <a16:creationId xmlns:a16="http://schemas.microsoft.com/office/drawing/2014/main" id="{DC1BAE4E-794F-41A2-8FFA-AE77D4129BE7}"/>
               </a:ext>
             </a:extLst>
           </p:cNvPr>
@@ -2153,7 +2153,7 @@
           <p:cNvPr id="7" name="">
             <a:extLst xmlns:a="http://schemas.openxmlformats.org/drawingml/2006/main">
               <a:ext uri="{FF2B5EF4-FFF2-40B4-BE49-F238E27FC236}">
-                <a16:creationId xmlns:a16="http://schemas.microsoft.com/office/drawing/2014/main" id="{291AF5CE-3E97-4B3E-9BCE-314DAE371695}"/>
+                <a16:creationId xmlns:a16="http://schemas.microsoft.com/office/drawing/2014/main" id="{418D3057-8CC9-4F64-8270-704AE0A0BBDA}"/>
               </a:ext>
             </a:extLst>
           </p:cNvPr>
@@ -2220,7 +2220,7 @@
           <p:cNvPr id="8" name="">
             <a:extLst xmlns:a="http://schemas.openxmlformats.org/drawingml/2006/main">
               <a:ext uri="{FF2B5EF4-FFF2-40B4-BE49-F238E27FC236}">
-                <a16:creationId xmlns:a16="http://schemas.microsoft.com/office/drawing/2014/main" id="{6F4B913E-A3DF-4442-A101-0885914CAC9C}"/>
+                <a16:creationId xmlns:a16="http://schemas.microsoft.com/office/drawing/2014/main" id="{3D9D684A-AFDF-44A7-AEF1-C4E2AFFBAA3C}"/>
               </a:ext>
             </a:extLst>
           </p:cNvPr>
@@ -2268,7 +2268,7 @@
     </p:spTree>
     <p:extLst>
       <p:ext uri="{BB962C8B-B14F-4D97-AF65-F5344CB8AC3E}">
-        <p14:creationId xmlns:p14="http://schemas.microsoft.com/office/powerpoint/2010/main" val="1220178999"/>
+        <p14:creationId xmlns:p14="http://schemas.microsoft.com/office/powerpoint/2010/main" val="688972989"/>
       </p:ext>
     </p:extLst>
   </p:cSld>
@@ -2299,7 +2299,7 @@
           <p:cNvPr id="12" name="">
             <a:extLst xmlns:a="http://schemas.openxmlformats.org/drawingml/2006/main">
               <a:ext uri="{FF2B5EF4-FFF2-40B4-BE49-F238E27FC236}">
-                <a16:creationId xmlns:a16="http://schemas.microsoft.com/office/drawing/2014/main" id="{94E73B12-527B-498B-B7BF-16BBE81F3D68}"/>
+                <a16:creationId xmlns:a16="http://schemas.microsoft.com/office/drawing/2014/main" id="{EDC43BEA-A44C-45AA-A4D5-05CE5B36A954}"/>
               </a:ext>
             </a:extLst>
           </p:cNvPr>
@@ -2349,7 +2349,7 @@
           <p:cNvPr id="2" name="">
             <a:extLst xmlns:a="http://schemas.openxmlformats.org/drawingml/2006/main">
               <a:ext uri="{FF2B5EF4-FFF2-40B4-BE49-F238E27FC236}">
-                <a16:creationId xmlns:a16="http://schemas.microsoft.com/office/drawing/2014/main" id="{433DF5C0-6736-42EF-A8E9-D7C07AFF80A9}"/>
+                <a16:creationId xmlns:a16="http://schemas.microsoft.com/office/drawing/2014/main" id="{62ECEF70-9D84-490A-B97D-C7DCB344D687}"/>
               </a:ext>
             </a:extLst>
           </p:cNvPr>
@@ -2399,7 +2399,7 @@
           <p:cNvPr id="3" name="">
             <a:extLst xmlns:a="http://schemas.openxmlformats.org/drawingml/2006/main">
               <a:ext uri="{FF2B5EF4-FFF2-40B4-BE49-F238E27FC236}">
-                <a16:creationId xmlns:a16="http://schemas.microsoft.com/office/drawing/2014/main" id="{EF96B9CF-1B24-4778-B4F8-B0EB1D5BCF53}"/>
+                <a16:creationId xmlns:a16="http://schemas.microsoft.com/office/drawing/2014/main" id="{31040470-0E1E-46F0-8519-9075441D04C3}"/>
               </a:ext>
             </a:extLst>
           </p:cNvPr>
@@ -2430,7 +2430,7 @@
           <p:cNvPr id="4" name="">
             <a:extLst xmlns:a="http://schemas.openxmlformats.org/drawingml/2006/main">
               <a:ext uri="{FF2B5EF4-FFF2-40B4-BE49-F238E27FC236}">
-                <a16:creationId xmlns:a16="http://schemas.microsoft.com/office/drawing/2014/main" id="{EB9B9224-B19F-4A2C-ADE2-2EEAEA61101E}"/>
+                <a16:creationId xmlns:a16="http://schemas.microsoft.com/office/drawing/2014/main" id="{67FE885E-8475-4019-A734-BF129A07A0F4}"/>
               </a:ext>
             </a:extLst>
           </p:cNvPr>
@@ -2480,7 +2480,7 @@
           <p:cNvPr id="5" name="">
             <a:extLst xmlns:a="http://schemas.openxmlformats.org/drawingml/2006/main">
               <a:ext uri="{FF2B5EF4-FFF2-40B4-BE49-F238E27FC236}">
-                <a16:creationId xmlns:a16="http://schemas.microsoft.com/office/drawing/2014/main" id="{12B6387F-0B70-490D-90A8-DAA9D7936DB2}"/>
+                <a16:creationId xmlns:a16="http://schemas.microsoft.com/office/drawing/2014/main" id="{76F864BD-E49E-47BA-993B-0295CD859073}"/>
               </a:ext>
             </a:extLst>
           </p:cNvPr>
@@ -2530,7 +2530,7 @@
           <p:cNvPr id="6" name="">
             <a:extLst xmlns:a="http://schemas.openxmlformats.org/drawingml/2006/main">
               <a:ext uri="{FF2B5EF4-FFF2-40B4-BE49-F238E27FC236}">
-                <a16:creationId xmlns:a16="http://schemas.microsoft.com/office/drawing/2014/main" id="{881A5AAF-21E2-4010-A096-096735BE1EDA}"/>
+                <a16:creationId xmlns:a16="http://schemas.microsoft.com/office/drawing/2014/main" id="{B46BE9E4-6889-498E-B302-6093447774A5}"/>
               </a:ext>
             </a:extLst>
           </p:cNvPr>
@@ -2580,7 +2580,7 @@
           <p:cNvPr id="7" name="">
             <a:extLst xmlns:a="http://schemas.openxmlformats.org/drawingml/2006/main">
               <a:ext uri="{FF2B5EF4-FFF2-40B4-BE49-F238E27FC236}">
-                <a16:creationId xmlns:a16="http://schemas.microsoft.com/office/drawing/2014/main" id="{874DAB12-C30B-4109-A522-689835DB571B}"/>
+                <a16:creationId xmlns:a16="http://schemas.microsoft.com/office/drawing/2014/main" id="{6964FF46-AA4A-4674-AB2B-A982D810394F}"/>
               </a:ext>
             </a:extLst>
           </p:cNvPr>
@@ -2637,7 +2637,7 @@
         </p:xfrm>
         <a:graphic xmlns:a="http://schemas.openxmlformats.org/drawingml/2006/main">
           <a:graphicData uri="http://schemas.openxmlformats.org/drawingml/2006/chart">
-            <c:chart xmlns:r="http://schemas.openxmlformats.org/officeDocument/2006/relationships" xmlns:c="http://schemas.openxmlformats.org/drawingml/2006/chart" r:id="Rffab79ba64934bdb"/>
+            <c:chart xmlns:r="http://schemas.openxmlformats.org/officeDocument/2006/relationships" xmlns:c="http://schemas.openxmlformats.org/drawingml/2006/chart" r:id="R8772e06f86984760"/>
           </a:graphicData>
         </a:graphic>
       </p:graphicFrame>
@@ -2646,7 +2646,7 @@
           <p:cNvPr id="9" name="">
             <a:extLst xmlns:a="http://schemas.openxmlformats.org/drawingml/2006/main">
               <a:ext uri="{FF2B5EF4-FFF2-40B4-BE49-F238E27FC236}">
-                <a16:creationId xmlns:a16="http://schemas.microsoft.com/office/drawing/2014/main" id="{B473195F-41AB-40ED-A0C7-60506151645A}"/>
+                <a16:creationId xmlns:a16="http://schemas.microsoft.com/office/drawing/2014/main" id="{8F707BC1-6154-4FDA-9DD5-607E935F0777}"/>
               </a:ext>
             </a:extLst>
           </p:cNvPr>
@@ -2681,7 +2681,7 @@
           <p:cNvPr id="10" name="">
             <a:extLst xmlns:a="http://schemas.openxmlformats.org/drawingml/2006/main">
               <a:ext uri="{FF2B5EF4-FFF2-40B4-BE49-F238E27FC236}">
-                <a16:creationId xmlns:a16="http://schemas.microsoft.com/office/drawing/2014/main" id="{23976D61-C9E4-4A69-AE3B-0D9C05F9FFBA}"/>
+                <a16:creationId xmlns:a16="http://schemas.microsoft.com/office/drawing/2014/main" id="{DB39A647-3DA4-40AE-81C8-EDDB018BB563}"/>
               </a:ext>
             </a:extLst>
           </p:cNvPr>
@@ -2731,7 +2731,7 @@
           <p:cNvPr id="11" name="">
             <a:extLst xmlns:a="http://schemas.openxmlformats.org/drawingml/2006/main">
               <a:ext uri="{FF2B5EF4-FFF2-40B4-BE49-F238E27FC236}">
-                <a16:creationId xmlns:a16="http://schemas.microsoft.com/office/drawing/2014/main" id="{0EB1C20F-1E1A-4ABF-B4FE-65C5D0DF18EB}"/>
+                <a16:creationId xmlns:a16="http://schemas.microsoft.com/office/drawing/2014/main" id="{A755F2FA-8C1E-432C-840E-9565A1BAF7F5}"/>
               </a:ext>
             </a:extLst>
           </p:cNvPr>
@@ -2779,7 +2779,7 @@
     </p:spTree>
     <p:extLst>
       <p:ext uri="{BB962C8B-B14F-4D97-AF65-F5344CB8AC3E}">
-        <p14:creationId xmlns:p14="http://schemas.microsoft.com/office/powerpoint/2010/main" val="401906617"/>
+        <p14:creationId xmlns:p14="http://schemas.microsoft.com/office/powerpoint/2010/main" val="1231765690"/>
       </p:ext>
     </p:extLst>
   </p:cSld>
@@ -2810,7 +2810,7 @@
           <p:cNvPr id="20" name="">
             <a:extLst xmlns:a="http://schemas.openxmlformats.org/drawingml/2006/main">
               <a:ext uri="{FF2B5EF4-FFF2-40B4-BE49-F238E27FC236}">
-                <a16:creationId xmlns:a16="http://schemas.microsoft.com/office/drawing/2014/main" id="{00160072-3F00-46E0-91CC-34C400F41724}"/>
+                <a16:creationId xmlns:a16="http://schemas.microsoft.com/office/drawing/2014/main" id="{D78D0537-BB29-4389-9423-AA4924E0439E}"/>
               </a:ext>
             </a:extLst>
           </p:cNvPr>
@@ -2860,7 +2860,7 @@
           <p:cNvPr id="2" name="">
             <a:extLst xmlns:a="http://schemas.openxmlformats.org/drawingml/2006/main">
               <a:ext uri="{FF2B5EF4-FFF2-40B4-BE49-F238E27FC236}">
-                <a16:creationId xmlns:a16="http://schemas.microsoft.com/office/drawing/2014/main" id="{F9B2DF19-EC0A-402F-9429-1B153E3A7E18}"/>
+                <a16:creationId xmlns:a16="http://schemas.microsoft.com/office/drawing/2014/main" id="{E6F96CB0-D645-43B0-A406-4DEB5F80772D}"/>
               </a:ext>
             </a:extLst>
           </p:cNvPr>
@@ -2910,7 +2910,7 @@
           <p:cNvPr id="3" name="">
             <a:extLst xmlns:a="http://schemas.openxmlformats.org/drawingml/2006/main">
               <a:ext uri="{FF2B5EF4-FFF2-40B4-BE49-F238E27FC236}">
-                <a16:creationId xmlns:a16="http://schemas.microsoft.com/office/drawing/2014/main" id="{D598256C-56B9-490F-A56C-9992D34A3BD6}"/>
+                <a16:creationId xmlns:a16="http://schemas.microsoft.com/office/drawing/2014/main" id="{6A2A8AFF-0BED-48D6-9799-EEF051FD8C2A}"/>
               </a:ext>
             </a:extLst>
           </p:cNvPr>
@@ -2941,7 +2941,7 @@
           <p:cNvPr id="4" name="">
             <a:extLst xmlns:a="http://schemas.openxmlformats.org/drawingml/2006/main">
               <a:ext uri="{FF2B5EF4-FFF2-40B4-BE49-F238E27FC236}">
-                <a16:creationId xmlns:a16="http://schemas.microsoft.com/office/drawing/2014/main" id="{DB015E39-C08F-4B5F-9415-423646F4A0C7}"/>
+                <a16:creationId xmlns:a16="http://schemas.microsoft.com/office/drawing/2014/main" id="{E6551B28-9E46-40ED-90A5-C31644B70A5E}"/>
               </a:ext>
             </a:extLst>
           </p:cNvPr>
@@ -2991,7 +2991,7 @@
           <p:cNvPr id="5" name="">
             <a:extLst xmlns:a="http://schemas.openxmlformats.org/drawingml/2006/main">
               <a:ext uri="{FF2B5EF4-FFF2-40B4-BE49-F238E27FC236}">
-                <a16:creationId xmlns:a16="http://schemas.microsoft.com/office/drawing/2014/main" id="{25A5BE60-8274-48AC-A067-574A0C489F9B}"/>
+                <a16:creationId xmlns:a16="http://schemas.microsoft.com/office/drawing/2014/main" id="{7CE60667-E746-4BC4-B160-F2FBBBDD1A39}"/>
               </a:ext>
             </a:extLst>
           </p:cNvPr>
@@ -3041,7 +3041,7 @@
           <p:cNvPr id="6" name="">
             <a:extLst xmlns:a="http://schemas.openxmlformats.org/drawingml/2006/main">
               <a:ext uri="{FF2B5EF4-FFF2-40B4-BE49-F238E27FC236}">
-                <a16:creationId xmlns:a16="http://schemas.microsoft.com/office/drawing/2014/main" id="{FAB597C8-1C3C-472A-A3F6-FCD9F4DF0679}"/>
+                <a16:creationId xmlns:a16="http://schemas.microsoft.com/office/drawing/2014/main" id="{03288153-CA6F-4010-A345-4BE6D7E74981}"/>
               </a:ext>
             </a:extLst>
           </p:cNvPr>
@@ -3091,7 +3091,7 @@
           <p:cNvPr id="7" name="">
             <a:extLst xmlns:a="http://schemas.openxmlformats.org/drawingml/2006/main">
               <a:ext uri="{FF2B5EF4-FFF2-40B4-BE49-F238E27FC236}">
-                <a16:creationId xmlns:a16="http://schemas.microsoft.com/office/drawing/2014/main" id="{2BE2A503-2C08-4907-96BA-AA5C445ECA6A}"/>
+                <a16:creationId xmlns:a16="http://schemas.microsoft.com/office/drawing/2014/main" id="{6A537179-1847-4533-BB32-5791C3A6D8F3}"/>
               </a:ext>
             </a:extLst>
           </p:cNvPr>
@@ -3141,7 +3141,7 @@
           <p:cNvPr id="8" name="">
             <a:extLst xmlns:a="http://schemas.openxmlformats.org/drawingml/2006/main">
               <a:ext uri="{FF2B5EF4-FFF2-40B4-BE49-F238E27FC236}">
-                <a16:creationId xmlns:a16="http://schemas.microsoft.com/office/drawing/2014/main" id="{246C3B6A-E2E6-4E7F-A999-DB67CF51F2DC}"/>
+                <a16:creationId xmlns:a16="http://schemas.microsoft.com/office/drawing/2014/main" id="{D1C4F1AC-C632-4C71-8A1D-15D7C29ECB2C}"/>
               </a:ext>
             </a:extLst>
           </p:cNvPr>
@@ -3172,7 +3172,7 @@
           <p:cNvPr id="9" name="">
             <a:extLst xmlns:a="http://schemas.openxmlformats.org/drawingml/2006/main">
               <a:ext uri="{FF2B5EF4-FFF2-40B4-BE49-F238E27FC236}">
-                <a16:creationId xmlns:a16="http://schemas.microsoft.com/office/drawing/2014/main" id="{784016ED-B6A4-42C7-B13A-9C86243926B6}"/>
+                <a16:creationId xmlns:a16="http://schemas.microsoft.com/office/drawing/2014/main" id="{EF1E22BD-46E6-4A6F-82F7-087F99D82AD8}"/>
               </a:ext>
             </a:extLst>
           </p:cNvPr>
@@ -3222,7 +3222,7 @@
           <p:cNvPr id="10" name="">
             <a:extLst xmlns:a="http://schemas.openxmlformats.org/drawingml/2006/main">
               <a:ext uri="{FF2B5EF4-FFF2-40B4-BE49-F238E27FC236}">
-                <a16:creationId xmlns:a16="http://schemas.microsoft.com/office/drawing/2014/main" id="{9B95D59D-1FC1-4C41-A819-A729430B92BD}"/>
+                <a16:creationId xmlns:a16="http://schemas.microsoft.com/office/drawing/2014/main" id="{2F4A8297-295E-4F0D-AB42-8B2D0D60AD42}"/>
               </a:ext>
             </a:extLst>
           </p:cNvPr>
@@ -3272,7 +3272,7 @@
           <p:cNvPr id="11" name="">
             <a:extLst xmlns:a="http://schemas.openxmlformats.org/drawingml/2006/main">
               <a:ext uri="{FF2B5EF4-FFF2-40B4-BE49-F238E27FC236}">
-                <a16:creationId xmlns:a16="http://schemas.microsoft.com/office/drawing/2014/main" id="{9F843792-8421-4B26-9465-0491895F1936}"/>
+                <a16:creationId xmlns:a16="http://schemas.microsoft.com/office/drawing/2014/main" id="{3470957E-46F0-4350-8223-0C22A2835B11}"/>
               </a:ext>
             </a:extLst>
           </p:cNvPr>
@@ -3303,7 +3303,7 @@
           <p:cNvPr id="12" name="">
             <a:extLst xmlns:a="http://schemas.openxmlformats.org/drawingml/2006/main">
               <a:ext uri="{FF2B5EF4-FFF2-40B4-BE49-F238E27FC236}">
-                <a16:creationId xmlns:a16="http://schemas.microsoft.com/office/drawing/2014/main" id="{EA930231-3A62-4DF3-B1E2-BD683B39FBFB}"/>
+                <a16:creationId xmlns:a16="http://schemas.microsoft.com/office/drawing/2014/main" id="{FF499D60-760A-43D5-A902-4607E2145FD8}"/>
               </a:ext>
             </a:extLst>
           </p:cNvPr>
@@ -3353,7 +3353,7 @@
           <p:cNvPr id="13" name="">
             <a:extLst xmlns:a="http://schemas.openxmlformats.org/drawingml/2006/main">
               <a:ext uri="{FF2B5EF4-FFF2-40B4-BE49-F238E27FC236}">
-                <a16:creationId xmlns:a16="http://schemas.microsoft.com/office/drawing/2014/main" id="{F3D7283A-44B7-4AA6-AE6C-FF4A077BBFB4}"/>
+                <a16:creationId xmlns:a16="http://schemas.microsoft.com/office/drawing/2014/main" id="{46A41865-3EC4-4D54-9125-168B5032A344}"/>
               </a:ext>
             </a:extLst>
           </p:cNvPr>
@@ -3403,7 +3403,7 @@
           <p:cNvPr id="14" name="">
             <a:extLst xmlns:a="http://schemas.openxmlformats.org/drawingml/2006/main">
               <a:ext uri="{FF2B5EF4-FFF2-40B4-BE49-F238E27FC236}">
-                <a16:creationId xmlns:a16="http://schemas.microsoft.com/office/drawing/2014/main" id="{BA80A450-1BCB-41B8-9444-A395AF621200}"/>
+                <a16:creationId xmlns:a16="http://schemas.microsoft.com/office/drawing/2014/main" id="{0B0AD72F-AF10-4E89-AFC1-8C658856CD97}"/>
               </a:ext>
             </a:extLst>
           </p:cNvPr>
@@ -3434,7 +3434,7 @@
           <p:cNvPr id="15" name="">
             <a:extLst xmlns:a="http://schemas.openxmlformats.org/drawingml/2006/main">
               <a:ext uri="{FF2B5EF4-FFF2-40B4-BE49-F238E27FC236}">
-                <a16:creationId xmlns:a16="http://schemas.microsoft.com/office/drawing/2014/main" id="{CC6A4CE1-DF2B-413E-BF8E-DAFF83B082D7}"/>
+                <a16:creationId xmlns:a16="http://schemas.microsoft.com/office/drawing/2014/main" id="{86DC97CE-9344-4EFC-AC27-756C202A4D60}"/>
               </a:ext>
             </a:extLst>
           </p:cNvPr>
@@ -3484,7 +3484,7 @@
           <p:cNvPr id="16" name="">
             <a:extLst xmlns:a="http://schemas.openxmlformats.org/drawingml/2006/main">
               <a:ext uri="{FF2B5EF4-FFF2-40B4-BE49-F238E27FC236}">
-                <a16:creationId xmlns:a16="http://schemas.microsoft.com/office/drawing/2014/main" id="{BA5066F0-33E8-4DFC-A24D-E88AC5823875}"/>
+                <a16:creationId xmlns:a16="http://schemas.microsoft.com/office/drawing/2014/main" id="{24A8A553-4006-42E4-BF47-5D6BD0BB58EB}"/>
               </a:ext>
             </a:extLst>
           </p:cNvPr>
@@ -3534,7 +3534,7 @@
           <p:cNvPr id="17" name="">
             <a:extLst xmlns:a="http://schemas.openxmlformats.org/drawingml/2006/main">
               <a:ext uri="{FF2B5EF4-FFF2-40B4-BE49-F238E27FC236}">
-                <a16:creationId xmlns:a16="http://schemas.microsoft.com/office/drawing/2014/main" id="{6EB2309B-D321-4A57-B2B5-CAB40AFDC87A}"/>
+                <a16:creationId xmlns:a16="http://schemas.microsoft.com/office/drawing/2014/main" id="{40F0EBAB-195A-492A-A45B-32D88446FEC1}"/>
               </a:ext>
             </a:extLst>
           </p:cNvPr>
@@ -3565,7 +3565,7 @@
           <p:cNvPr id="18" name="">
             <a:extLst xmlns:a="http://schemas.openxmlformats.org/drawingml/2006/main">
               <a:ext uri="{FF2B5EF4-FFF2-40B4-BE49-F238E27FC236}">
-                <a16:creationId xmlns:a16="http://schemas.microsoft.com/office/drawing/2014/main" id="{096C3FD8-1256-459A-9202-50A59A015490}"/>
+                <a16:creationId xmlns:a16="http://schemas.microsoft.com/office/drawing/2014/main" id="{376BBFF0-4F6F-4D9C-9CF3-2CA857D59B28}"/>
               </a:ext>
             </a:extLst>
           </p:cNvPr>
@@ -3615,7 +3615,7 @@
           <p:cNvPr id="19" name="">
             <a:extLst xmlns:a="http://schemas.openxmlformats.org/drawingml/2006/main">
               <a:ext uri="{FF2B5EF4-FFF2-40B4-BE49-F238E27FC236}">
-                <a16:creationId xmlns:a16="http://schemas.microsoft.com/office/drawing/2014/main" id="{B2CCC792-E855-47B1-A3AB-4EDD86F3A69D}"/>
+                <a16:creationId xmlns:a16="http://schemas.microsoft.com/office/drawing/2014/main" id="{9B99C817-29CE-4032-B480-1B02E4F4F54A}"/>
               </a:ext>
             </a:extLst>
           </p:cNvPr>
@@ -3663,7 +3663,7 @@
     </p:spTree>
     <p:extLst>
       <p:ext uri="{BB962C8B-B14F-4D97-AF65-F5344CB8AC3E}">
-        <p14:creationId xmlns:p14="http://schemas.microsoft.com/office/powerpoint/2010/main" val="933073361"/>
+        <p14:creationId xmlns:p14="http://schemas.microsoft.com/office/powerpoint/2010/main" val="1102940483"/>
       </p:ext>
     </p:extLst>
   </p:cSld>
@@ -3694,7 +3694,7 @@
           <p:cNvPr id="20" name="">
             <a:extLst xmlns:a="http://schemas.openxmlformats.org/drawingml/2006/main">
               <a:ext uri="{FF2B5EF4-FFF2-40B4-BE49-F238E27FC236}">
-                <a16:creationId xmlns:a16="http://schemas.microsoft.com/office/drawing/2014/main" id="{57D9D47A-7672-4BA6-ADE7-22658B1D3DCA}"/>
+                <a16:creationId xmlns:a16="http://schemas.microsoft.com/office/drawing/2014/main" id="{18CF7DC8-D949-4CD5-9F5B-266FA632222F}"/>
               </a:ext>
             </a:extLst>
           </p:cNvPr>
@@ -3744,7 +3744,7 @@
           <p:cNvPr id="2" name="">
             <a:extLst xmlns:a="http://schemas.openxmlformats.org/drawingml/2006/main">
               <a:ext uri="{FF2B5EF4-FFF2-40B4-BE49-F238E27FC236}">
-                <a16:creationId xmlns:a16="http://schemas.microsoft.com/office/drawing/2014/main" id="{FF5C13C0-B860-4E44-8F32-B14ACE62AF39}"/>
+                <a16:creationId xmlns:a16="http://schemas.microsoft.com/office/drawing/2014/main" id="{FB5D3570-E9F4-4AC3-8DFA-3B2928A7A5EF}"/>
               </a:ext>
             </a:extLst>
           </p:cNvPr>
@@ -3794,7 +3794,7 @@
           <p:cNvPr id="3" name="">
             <a:extLst xmlns:a="http://schemas.openxmlformats.org/drawingml/2006/main">
               <a:ext uri="{FF2B5EF4-FFF2-40B4-BE49-F238E27FC236}">
-                <a16:creationId xmlns:a16="http://schemas.microsoft.com/office/drawing/2014/main" id="{19DEAC89-51E3-406B-BD41-FEDDB97F6BC3}"/>
+                <a16:creationId xmlns:a16="http://schemas.microsoft.com/office/drawing/2014/main" id="{F031D396-CA75-4D7F-AFDF-96FCA5734D75}"/>
               </a:ext>
             </a:extLst>
           </p:cNvPr>
@@ -3825,7 +3825,7 @@
           <p:cNvPr id="4" name="">
             <a:extLst xmlns:a="http://schemas.openxmlformats.org/drawingml/2006/main">
               <a:ext uri="{FF2B5EF4-FFF2-40B4-BE49-F238E27FC236}">
-                <a16:creationId xmlns:a16="http://schemas.microsoft.com/office/drawing/2014/main" id="{FF4EC71E-FD94-46B0-A451-9DCE75356E5A}"/>
+                <a16:creationId xmlns:a16="http://schemas.microsoft.com/office/drawing/2014/main" id="{9DC5741A-2B27-4053-A41C-E7E97C5DC2C5}"/>
               </a:ext>
             </a:extLst>
           </p:cNvPr>
@@ -3875,7 +3875,7 @@
           <p:cNvPr id="5" name="">
             <a:extLst xmlns:a="http://schemas.openxmlformats.org/drawingml/2006/main">
               <a:ext uri="{FF2B5EF4-FFF2-40B4-BE49-F238E27FC236}">
-                <a16:creationId xmlns:a16="http://schemas.microsoft.com/office/drawing/2014/main" id="{758BFE54-54A3-45FE-A82D-169BFB6D5251}"/>
+                <a16:creationId xmlns:a16="http://schemas.microsoft.com/office/drawing/2014/main" id="{07DFA665-E215-4B46-939A-01FE5E224495}"/>
               </a:ext>
             </a:extLst>
           </p:cNvPr>
@@ -3925,7 +3925,7 @@
           <p:cNvPr id="6" name="">
             <a:extLst xmlns:a="http://schemas.openxmlformats.org/drawingml/2006/main">
               <a:ext uri="{FF2B5EF4-FFF2-40B4-BE49-F238E27FC236}">
-                <a16:creationId xmlns:a16="http://schemas.microsoft.com/office/drawing/2014/main" id="{93D70C58-51BB-4E2E-AB92-22E9914C23B2}"/>
+                <a16:creationId xmlns:a16="http://schemas.microsoft.com/office/drawing/2014/main" id="{AFCFCA69-4524-4C59-95BA-31A51F2533A0}"/>
               </a:ext>
             </a:extLst>
           </p:cNvPr>
@@ -3975,7 +3975,7 @@
           <p:cNvPr id="7" name="">
             <a:extLst xmlns:a="http://schemas.openxmlformats.org/drawingml/2006/main">
               <a:ext uri="{FF2B5EF4-FFF2-40B4-BE49-F238E27FC236}">
-                <a16:creationId xmlns:a16="http://schemas.microsoft.com/office/drawing/2014/main" id="{293D7865-017C-44BC-8110-991B378B7EE4}"/>
+                <a16:creationId xmlns:a16="http://schemas.microsoft.com/office/drawing/2014/main" id="{A3F24018-5735-41FC-9E1F-4BA86BCCFD87}"/>
               </a:ext>
             </a:extLst>
           </p:cNvPr>
@@ -4025,7 +4025,7 @@
           <p:cNvPr id="8" name="">
             <a:extLst xmlns:a="http://schemas.openxmlformats.org/drawingml/2006/main">
               <a:ext uri="{FF2B5EF4-FFF2-40B4-BE49-F238E27FC236}">
-                <a16:creationId xmlns:a16="http://schemas.microsoft.com/office/drawing/2014/main" id="{88903EC9-B5D7-46A2-B023-54A067AFDB36}"/>
+                <a16:creationId xmlns:a16="http://schemas.microsoft.com/office/drawing/2014/main" id="{C5BC0909-0CE4-47DE-8FD5-A4FA9D68915B}"/>
               </a:ext>
             </a:extLst>
           </p:cNvPr>
@@ -4056,7 +4056,7 @@
           <p:cNvPr id="9" name="">
             <a:extLst xmlns:a="http://schemas.openxmlformats.org/drawingml/2006/main">
               <a:ext uri="{FF2B5EF4-FFF2-40B4-BE49-F238E27FC236}">
-                <a16:creationId xmlns:a16="http://schemas.microsoft.com/office/drawing/2014/main" id="{FC55D82B-3F67-4182-890A-1B8DE8269247}"/>
+                <a16:creationId xmlns:a16="http://schemas.microsoft.com/office/drawing/2014/main" id="{905A4785-23F9-4684-B272-E02151501EB6}"/>
               </a:ext>
             </a:extLst>
           </p:cNvPr>
@@ -4106,7 +4106,7 @@
           <p:cNvPr id="10" name="">
             <a:extLst xmlns:a="http://schemas.openxmlformats.org/drawingml/2006/main">
               <a:ext uri="{FF2B5EF4-FFF2-40B4-BE49-F238E27FC236}">
-                <a16:creationId xmlns:a16="http://schemas.microsoft.com/office/drawing/2014/main" id="{B9157CE4-D9F9-442F-A688-155F5AB0E7D8}"/>
+                <a16:creationId xmlns:a16="http://schemas.microsoft.com/office/drawing/2014/main" id="{B7F7ED6D-12CD-436D-8E41-1B785BA7CC9A}"/>
               </a:ext>
             </a:extLst>
           </p:cNvPr>
@@ -4156,7 +4156,7 @@
           <p:cNvPr id="11" name="">
             <a:extLst xmlns:a="http://schemas.openxmlformats.org/drawingml/2006/main">
               <a:ext uri="{FF2B5EF4-FFF2-40B4-BE49-F238E27FC236}">
-                <a16:creationId xmlns:a16="http://schemas.microsoft.com/office/drawing/2014/main" id="{924313AF-5605-4961-8F39-6D11AE95D8DD}"/>
+                <a16:creationId xmlns:a16="http://schemas.microsoft.com/office/drawing/2014/main" id="{F05BC961-F054-4ADA-97EB-2874BDDC8CBF}"/>
               </a:ext>
             </a:extLst>
           </p:cNvPr>
@@ -4187,7 +4187,7 @@
           <p:cNvPr id="12" name="">
             <a:extLst xmlns:a="http://schemas.openxmlformats.org/drawingml/2006/main">
               <a:ext uri="{FF2B5EF4-FFF2-40B4-BE49-F238E27FC236}">
-                <a16:creationId xmlns:a16="http://schemas.microsoft.com/office/drawing/2014/main" id="{BF3AEFB7-8498-49DB-BB0A-3CDE34D3F76F}"/>
+                <a16:creationId xmlns:a16="http://schemas.microsoft.com/office/drawing/2014/main" id="{3FBBFD84-AFDC-4A8A-9917-46D7E386B0DC}"/>
               </a:ext>
             </a:extLst>
           </p:cNvPr>
@@ -4237,7 +4237,7 @@
           <p:cNvPr id="13" name="">
             <a:extLst xmlns:a="http://schemas.openxmlformats.org/drawingml/2006/main">
               <a:ext uri="{FF2B5EF4-FFF2-40B4-BE49-F238E27FC236}">
-                <a16:creationId xmlns:a16="http://schemas.microsoft.com/office/drawing/2014/main" id="{9C7E8F2F-57EF-4E4C-AD10-12CFAEB26B84}"/>
+                <a16:creationId xmlns:a16="http://schemas.microsoft.com/office/drawing/2014/main" id="{9E25BD9B-0FD1-4DEA-BAB5-5A7E42273AB8}"/>
               </a:ext>
             </a:extLst>
           </p:cNvPr>
@@ -4287,7 +4287,7 @@
           <p:cNvPr id="14" name="">
             <a:extLst xmlns:a="http://schemas.openxmlformats.org/drawingml/2006/main">
               <a:ext uri="{FF2B5EF4-FFF2-40B4-BE49-F238E27FC236}">
-                <a16:creationId xmlns:a16="http://schemas.microsoft.com/office/drawing/2014/main" id="{BF0FF045-76E0-4AE4-920E-5804113624DE}"/>
+                <a16:creationId xmlns:a16="http://schemas.microsoft.com/office/drawing/2014/main" id="{6D986D2F-1A46-4535-873E-A565132211D2}"/>
               </a:ext>
             </a:extLst>
           </p:cNvPr>
@@ -4318,7 +4318,7 @@
           <p:cNvPr id="15" name="">
             <a:extLst xmlns:a="http://schemas.openxmlformats.org/drawingml/2006/main">
               <a:ext uri="{FF2B5EF4-FFF2-40B4-BE49-F238E27FC236}">
-                <a16:creationId xmlns:a16="http://schemas.microsoft.com/office/drawing/2014/main" id="{6E439B1D-981A-408F-94E4-221376CDB5CF}"/>
+                <a16:creationId xmlns:a16="http://schemas.microsoft.com/office/drawing/2014/main" id="{215A42F1-38F0-457A-AA39-917B0A3B7268}"/>
               </a:ext>
             </a:extLst>
           </p:cNvPr>
@@ -4368,7 +4368,7 @@
           <p:cNvPr id="16" name="">
             <a:extLst xmlns:a="http://schemas.openxmlformats.org/drawingml/2006/main">
               <a:ext uri="{FF2B5EF4-FFF2-40B4-BE49-F238E27FC236}">
-                <a16:creationId xmlns:a16="http://schemas.microsoft.com/office/drawing/2014/main" id="{2E41186F-5FE5-4418-9220-C2BC2F1850B3}"/>
+                <a16:creationId xmlns:a16="http://schemas.microsoft.com/office/drawing/2014/main" id="{392ED102-E75C-4192-B9DB-D4440AB3BAAD}"/>
               </a:ext>
             </a:extLst>
           </p:cNvPr>
@@ -4418,7 +4418,7 @@
           <p:cNvPr id="17" name="">
             <a:extLst xmlns:a="http://schemas.openxmlformats.org/drawingml/2006/main">
               <a:ext uri="{FF2B5EF4-FFF2-40B4-BE49-F238E27FC236}">
-                <a16:creationId xmlns:a16="http://schemas.microsoft.com/office/drawing/2014/main" id="{EBC2557B-8168-4EBD-B6DC-497638F55C4E}"/>
+                <a16:creationId xmlns:a16="http://schemas.microsoft.com/office/drawing/2014/main" id="{3D2D3D25-62DB-497D-8600-7274797AF294}"/>
               </a:ext>
             </a:extLst>
           </p:cNvPr>
@@ -4449,7 +4449,7 @@
           <p:cNvPr id="18" name="">
             <a:extLst xmlns:a="http://schemas.openxmlformats.org/drawingml/2006/main">
               <a:ext uri="{FF2B5EF4-FFF2-40B4-BE49-F238E27FC236}">
-                <a16:creationId xmlns:a16="http://schemas.microsoft.com/office/drawing/2014/main" id="{53A6AA96-7CCD-4B77-899D-B363BE132A60}"/>
+                <a16:creationId xmlns:a16="http://schemas.microsoft.com/office/drawing/2014/main" id="{8E11FBDA-708B-43D5-B232-EE6596E42DD7}"/>
               </a:ext>
             </a:extLst>
           </p:cNvPr>
@@ -4499,7 +4499,7 @@
           <p:cNvPr id="19" name="">
             <a:extLst xmlns:a="http://schemas.openxmlformats.org/drawingml/2006/main">
               <a:ext uri="{FF2B5EF4-FFF2-40B4-BE49-F238E27FC236}">
-                <a16:creationId xmlns:a16="http://schemas.microsoft.com/office/drawing/2014/main" id="{A146D9D7-A350-459B-A5C0-B51FD8735735}"/>
+                <a16:creationId xmlns:a16="http://schemas.microsoft.com/office/drawing/2014/main" id="{65F467AB-1FC3-453B-8E18-D03B868D8A42}"/>
               </a:ext>
             </a:extLst>
           </p:cNvPr>
@@ -4547,7 +4547,7 @@
     </p:spTree>
     <p:extLst>
       <p:ext uri="{BB962C8B-B14F-4D97-AF65-F5344CB8AC3E}">
-        <p14:creationId xmlns:p14="http://schemas.microsoft.com/office/powerpoint/2010/main" val="1029269305"/>
+        <p14:creationId xmlns:p14="http://schemas.microsoft.com/office/powerpoint/2010/main" val="597404758"/>
       </p:ext>
     </p:extLst>
   </p:cSld>
@@ -4578,7 +4578,7 @@
           <p:cNvPr id="20" name="">
             <a:extLst xmlns:a="http://schemas.openxmlformats.org/drawingml/2006/main">
               <a:ext uri="{FF2B5EF4-FFF2-40B4-BE49-F238E27FC236}">
-                <a16:creationId xmlns:a16="http://schemas.microsoft.com/office/drawing/2014/main" id="{B0596BCA-F569-4D2F-AF59-E8B707EE8E0C}"/>
+                <a16:creationId xmlns:a16="http://schemas.microsoft.com/office/drawing/2014/main" id="{7F4F7E43-757E-45B0-B4BD-ADE2F0B74A00}"/>
               </a:ext>
             </a:extLst>
           </p:cNvPr>
@@ -4628,7 +4628,7 @@
           <p:cNvPr id="2" name="">
             <a:extLst xmlns:a="http://schemas.openxmlformats.org/drawingml/2006/main">
               <a:ext uri="{FF2B5EF4-FFF2-40B4-BE49-F238E27FC236}">
-                <a16:creationId xmlns:a16="http://schemas.microsoft.com/office/drawing/2014/main" id="{FEDDA17B-8BFD-4207-866A-252F68B3A04C}"/>
+                <a16:creationId xmlns:a16="http://schemas.microsoft.com/office/drawing/2014/main" id="{1B212684-4D80-4213-B89F-3E0B82E4919F}"/>
               </a:ext>
             </a:extLst>
           </p:cNvPr>
@@ -4678,7 +4678,7 @@
           <p:cNvPr id="3" name="">
             <a:extLst xmlns:a="http://schemas.openxmlformats.org/drawingml/2006/main">
               <a:ext uri="{FF2B5EF4-FFF2-40B4-BE49-F238E27FC236}">
-                <a16:creationId xmlns:a16="http://schemas.microsoft.com/office/drawing/2014/main" id="{E8A0B737-0FCC-4E7C-ACF3-FCC96B921D0D}"/>
+                <a16:creationId xmlns:a16="http://schemas.microsoft.com/office/drawing/2014/main" id="{3A991501-23E6-4E84-BF5F-C569EF5CE54C}"/>
               </a:ext>
             </a:extLst>
           </p:cNvPr>
@@ -4709,7 +4709,7 @@
           <p:cNvPr id="4" name="">
             <a:extLst xmlns:a="http://schemas.openxmlformats.org/drawingml/2006/main">
               <a:ext uri="{FF2B5EF4-FFF2-40B4-BE49-F238E27FC236}">
-                <a16:creationId xmlns:a16="http://schemas.microsoft.com/office/drawing/2014/main" id="{05D3AF48-85C1-480D-807E-95AEEC1F88B8}"/>
+                <a16:creationId xmlns:a16="http://schemas.microsoft.com/office/drawing/2014/main" id="{7C384191-57A0-4F58-A84B-77B556715468}"/>
               </a:ext>
             </a:extLst>
           </p:cNvPr>
@@ -4759,7 +4759,7 @@
           <p:cNvPr id="5" name="">
             <a:extLst xmlns:a="http://schemas.openxmlformats.org/drawingml/2006/main">
               <a:ext uri="{FF2B5EF4-FFF2-40B4-BE49-F238E27FC236}">
-                <a16:creationId xmlns:a16="http://schemas.microsoft.com/office/drawing/2014/main" id="{91A4295B-EEEF-4AC1-AED1-942DC0C4D0F6}"/>
+                <a16:creationId xmlns:a16="http://schemas.microsoft.com/office/drawing/2014/main" id="{B6892C81-D2BB-42F1-9B14-D83618E8687C}"/>
               </a:ext>
             </a:extLst>
           </p:cNvPr>
@@ -4809,7 +4809,7 @@
           <p:cNvPr id="6" name="">
             <a:extLst xmlns:a="http://schemas.openxmlformats.org/drawingml/2006/main">
               <a:ext uri="{FF2B5EF4-FFF2-40B4-BE49-F238E27FC236}">
-                <a16:creationId xmlns:a16="http://schemas.microsoft.com/office/drawing/2014/main" id="{8B53EA9F-9B19-4AFC-8F6D-0D9C9982B1D3}"/>
+                <a16:creationId xmlns:a16="http://schemas.microsoft.com/office/drawing/2014/main" id="{2AA05826-1052-46D3-8F52-2E32DEC431D2}"/>
               </a:ext>
             </a:extLst>
           </p:cNvPr>
@@ -4859,7 +4859,7 @@
           <p:cNvPr id="7" name="">
             <a:extLst xmlns:a="http://schemas.openxmlformats.org/drawingml/2006/main">
               <a:ext uri="{FF2B5EF4-FFF2-40B4-BE49-F238E27FC236}">
-                <a16:creationId xmlns:a16="http://schemas.microsoft.com/office/drawing/2014/main" id="{94B686A5-533A-4CE7-A2DB-2F1CACAFC00F}"/>
+                <a16:creationId xmlns:a16="http://schemas.microsoft.com/office/drawing/2014/main" id="{B9352811-09FE-4DBF-A0A0-244FE2BECCA2}"/>
               </a:ext>
             </a:extLst>
           </p:cNvPr>
@@ -4909,7 +4909,7 @@
           <p:cNvPr id="8" name="">
             <a:extLst xmlns:a="http://schemas.openxmlformats.org/drawingml/2006/main">
               <a:ext uri="{FF2B5EF4-FFF2-40B4-BE49-F238E27FC236}">
-                <a16:creationId xmlns:a16="http://schemas.microsoft.com/office/drawing/2014/main" id="{64844DAE-BFD9-49F6-A3E4-43181E6A018A}"/>
+                <a16:creationId xmlns:a16="http://schemas.microsoft.com/office/drawing/2014/main" id="{4259A7F8-AE22-442C-B2C3-26ED4415C5A9}"/>
               </a:ext>
             </a:extLst>
           </p:cNvPr>
@@ -4940,7 +4940,7 @@
           <p:cNvPr id="9" name="">
             <a:extLst xmlns:a="http://schemas.openxmlformats.org/drawingml/2006/main">
               <a:ext uri="{FF2B5EF4-FFF2-40B4-BE49-F238E27FC236}">
-                <a16:creationId xmlns:a16="http://schemas.microsoft.com/office/drawing/2014/main" id="{1D1080FF-9B87-4A5B-9AA6-3DDA91CE4B30}"/>
+                <a16:creationId xmlns:a16="http://schemas.microsoft.com/office/drawing/2014/main" id="{956A5481-7347-4FF7-BBE5-967BAA46C01D}"/>
               </a:ext>
             </a:extLst>
           </p:cNvPr>
@@ -4990,7 +4990,7 @@
           <p:cNvPr id="10" name="">
             <a:extLst xmlns:a="http://schemas.openxmlformats.org/drawingml/2006/main">
               <a:ext uri="{FF2B5EF4-FFF2-40B4-BE49-F238E27FC236}">
-                <a16:creationId xmlns:a16="http://schemas.microsoft.com/office/drawing/2014/main" id="{C2656B9A-E8BC-45F0-88F8-157AB7B9F945}"/>
+                <a16:creationId xmlns:a16="http://schemas.microsoft.com/office/drawing/2014/main" id="{31DF9A1D-1ECC-461A-B74E-7C2C2FC57D2A}"/>
               </a:ext>
             </a:extLst>
           </p:cNvPr>
@@ -5030,7 +5030,7 @@
                   <a:srgbClr val="17201E"/>
                 </a:solidFill>
               </a:rPr>
-              <a:t>Corporate chocolate enquiry guide</a:t>
+              <a:t>Sydney artisan chocolate shopping guide</a:t>
             </a:r>
           </a:p>
         </p:txBody>
@@ -5040,7 +5040,7 @@
           <p:cNvPr id="11" name="">
             <a:extLst xmlns:a="http://schemas.openxmlformats.org/drawingml/2006/main">
               <a:ext uri="{FF2B5EF4-FFF2-40B4-BE49-F238E27FC236}">
-                <a16:creationId xmlns:a16="http://schemas.microsoft.com/office/drawing/2014/main" id="{835B5F67-EFD7-481D-A483-54F85E256EF0}"/>
+                <a16:creationId xmlns:a16="http://schemas.microsoft.com/office/drawing/2014/main" id="{D90D9B8D-56E9-49C4-909F-F46B137F5BBE}"/>
               </a:ext>
             </a:extLst>
           </p:cNvPr>
@@ -5071,7 +5071,7 @@
           <p:cNvPr id="12" name="">
             <a:extLst xmlns:a="http://schemas.openxmlformats.org/drawingml/2006/main">
               <a:ext uri="{FF2B5EF4-FFF2-40B4-BE49-F238E27FC236}">
-                <a16:creationId xmlns:a16="http://schemas.microsoft.com/office/drawing/2014/main" id="{6022C699-446B-488D-9E7B-FC1FF6780AB6}"/>
+                <a16:creationId xmlns:a16="http://schemas.microsoft.com/office/drawing/2014/main" id="{0C4F5081-306A-4826-A02B-E8C7322BF8DD}"/>
               </a:ext>
             </a:extLst>
           </p:cNvPr>
@@ -5121,7 +5121,7 @@
           <p:cNvPr id="13" name="">
             <a:extLst xmlns:a="http://schemas.openxmlformats.org/drawingml/2006/main">
               <a:ext uri="{FF2B5EF4-FFF2-40B4-BE49-F238E27FC236}">
-                <a16:creationId xmlns:a16="http://schemas.microsoft.com/office/drawing/2014/main" id="{AA36FCEE-5FD6-4A64-B5F8-2C92E0316004}"/>
+                <a16:creationId xmlns:a16="http://schemas.microsoft.com/office/drawing/2014/main" id="{D5C0186E-D799-4CAC-8190-515DC19972F1}"/>
               </a:ext>
             </a:extLst>
           </p:cNvPr>
@@ -5161,7 +5161,7 @@
                   <a:srgbClr val="17201E"/>
                 </a:solidFill>
               </a:rPr>
-              <a:t>Wholesale enquiry guide</a:t>
+              <a:t>Chocolate gift box selection guide</a:t>
             </a:r>
           </a:p>
         </p:txBody>
@@ -5171,7 +5171,7 @@
           <p:cNvPr id="14" name="">
             <a:extLst xmlns:a="http://schemas.openxmlformats.org/drawingml/2006/main">
               <a:ext uri="{FF2B5EF4-FFF2-40B4-BE49-F238E27FC236}">
-                <a16:creationId xmlns:a16="http://schemas.microsoft.com/office/drawing/2014/main" id="{C05D3CAE-6AFB-47B5-AC5A-962116454325}"/>
+                <a16:creationId xmlns:a16="http://schemas.microsoft.com/office/drawing/2014/main" id="{BBDC057F-ACE5-4F3C-A79F-B3677DBBDB1A}"/>
               </a:ext>
             </a:extLst>
           </p:cNvPr>
@@ -5202,7 +5202,7 @@
           <p:cNvPr id="15" name="">
             <a:extLst xmlns:a="http://schemas.openxmlformats.org/drawingml/2006/main">
               <a:ext uri="{FF2B5EF4-FFF2-40B4-BE49-F238E27FC236}">
-                <a16:creationId xmlns:a16="http://schemas.microsoft.com/office/drawing/2014/main" id="{0E8E9CAA-0264-4E25-BA7D-C48F455BF4AC}"/>
+                <a16:creationId xmlns:a16="http://schemas.microsoft.com/office/drawing/2014/main" id="{83B1F8B4-906B-4C52-8771-213F1B34F1F3}"/>
               </a:ext>
             </a:extLst>
           </p:cNvPr>
@@ -5252,7 +5252,7 @@
           <p:cNvPr id="16" name="">
             <a:extLst xmlns:a="http://schemas.openxmlformats.org/drawingml/2006/main">
               <a:ext uri="{FF2B5EF4-FFF2-40B4-BE49-F238E27FC236}">
-                <a16:creationId xmlns:a16="http://schemas.microsoft.com/office/drawing/2014/main" id="{866BA623-74B2-474A-8E40-A53E669F9244}"/>
+                <a16:creationId xmlns:a16="http://schemas.microsoft.com/office/drawing/2014/main" id="{E3E1AD99-7987-48FD-ACFF-743A6DDD1E95}"/>
               </a:ext>
             </a:extLst>
           </p:cNvPr>
@@ -5292,7 +5292,7 @@
                   <a:srgbClr val="17201E"/>
                 </a:solidFill>
               </a:rPr>
-              <a:t>Chocolate delivery planning guide</a:t>
+              <a:t>Chocolate bar collection guide</a:t>
             </a:r>
           </a:p>
         </p:txBody>
@@ -5302,7 +5302,7 @@
           <p:cNvPr id="17" name="">
             <a:extLst xmlns:a="http://schemas.openxmlformats.org/drawingml/2006/main">
               <a:ext uri="{FF2B5EF4-FFF2-40B4-BE49-F238E27FC236}">
-                <a16:creationId xmlns:a16="http://schemas.microsoft.com/office/drawing/2014/main" id="{2BC7706A-BD6D-4CCF-8686-DA8CF28FBAD2}"/>
+                <a16:creationId xmlns:a16="http://schemas.microsoft.com/office/drawing/2014/main" id="{B04203FF-084E-41F2-97C1-E0070E4FFB75}"/>
               </a:ext>
             </a:extLst>
           </p:cNvPr>
@@ -5333,7 +5333,7 @@
           <p:cNvPr id="18" name="">
             <a:extLst xmlns:a="http://schemas.openxmlformats.org/drawingml/2006/main">
               <a:ext uri="{FF2B5EF4-FFF2-40B4-BE49-F238E27FC236}">
-                <a16:creationId xmlns:a16="http://schemas.microsoft.com/office/drawing/2014/main" id="{6D4186DC-639A-4994-AE9C-723550F905D0}"/>
+                <a16:creationId xmlns:a16="http://schemas.microsoft.com/office/drawing/2014/main" id="{AD8636B6-744C-47A5-8627-3A4C3B66F60F}"/>
               </a:ext>
             </a:extLst>
           </p:cNvPr>
@@ -5383,7 +5383,7 @@
           <p:cNvPr id="19" name="">
             <a:extLst xmlns:a="http://schemas.openxmlformats.org/drawingml/2006/main">
               <a:ext uri="{FF2B5EF4-FFF2-40B4-BE49-F238E27FC236}">
-                <a16:creationId xmlns:a16="http://schemas.microsoft.com/office/drawing/2014/main" id="{5CC3F932-9E92-491A-A919-37E97BAA08D7}"/>
+                <a16:creationId xmlns:a16="http://schemas.microsoft.com/office/drawing/2014/main" id="{FFDEC7DF-8FA8-4FA1-B061-313347A6EBE4}"/>
               </a:ext>
             </a:extLst>
           </p:cNvPr>
@@ -5423,7 +5423,7 @@
                   <a:srgbClr val="17201E"/>
                 </a:solidFill>
               </a:rPr>
-              <a:t>How Kakawa presents its craft</a:t>
+              <a:t>Praline and bonbon selection guide</a:t>
             </a:r>
           </a:p>
         </p:txBody>
@@ -5431,7 +5431,7 @@
     </p:spTree>
     <p:extLst>
       <p:ext uri="{BB962C8B-B14F-4D97-AF65-F5344CB8AC3E}">
-        <p14:creationId xmlns:p14="http://schemas.microsoft.com/office/powerpoint/2010/main" val="736645698"/>
+        <p14:creationId xmlns:p14="http://schemas.microsoft.com/office/powerpoint/2010/main" val="549043844"/>
       </p:ext>
     </p:extLst>
   </p:cSld>
@@ -5462,7 +5462,7 @@
           <p:cNvPr id="28" name="">
             <a:extLst xmlns:a="http://schemas.openxmlformats.org/drawingml/2006/main">
               <a:ext uri="{FF2B5EF4-FFF2-40B4-BE49-F238E27FC236}">
-                <a16:creationId xmlns:a16="http://schemas.microsoft.com/office/drawing/2014/main" id="{EBA91E5B-7179-48A7-BC65-5F6022D73E76}"/>
+                <a16:creationId xmlns:a16="http://schemas.microsoft.com/office/drawing/2014/main" id="{ABF1C1FB-3780-4CA2-810F-AE5858531150}"/>
               </a:ext>
             </a:extLst>
           </p:cNvPr>
@@ -5512,7 +5512,7 @@
           <p:cNvPr id="2" name="">
             <a:extLst xmlns:a="http://schemas.openxmlformats.org/drawingml/2006/main">
               <a:ext uri="{FF2B5EF4-FFF2-40B4-BE49-F238E27FC236}">
-                <a16:creationId xmlns:a16="http://schemas.microsoft.com/office/drawing/2014/main" id="{2EFAF1F6-8453-4A83-941D-B7412393872F}"/>
+                <a16:creationId xmlns:a16="http://schemas.microsoft.com/office/drawing/2014/main" id="{4FFD1541-8D17-4890-B0CF-9C6C1F4F9C0A}"/>
               </a:ext>
             </a:extLst>
           </p:cNvPr>
@@ -5562,7 +5562,7 @@
           <p:cNvPr id="3" name="">
             <a:extLst xmlns:a="http://schemas.openxmlformats.org/drawingml/2006/main">
               <a:ext uri="{FF2B5EF4-FFF2-40B4-BE49-F238E27FC236}">
-                <a16:creationId xmlns:a16="http://schemas.microsoft.com/office/drawing/2014/main" id="{F7C915BE-1A1D-4C4C-9D37-DF19723A8883}"/>
+                <a16:creationId xmlns:a16="http://schemas.microsoft.com/office/drawing/2014/main" id="{BC2250C9-CCCE-4DA8-A669-7B872E59B58D}"/>
               </a:ext>
             </a:extLst>
           </p:cNvPr>
@@ -5593,7 +5593,7 @@
           <p:cNvPr id="4" name="">
             <a:extLst xmlns:a="http://schemas.openxmlformats.org/drawingml/2006/main">
               <a:ext uri="{FF2B5EF4-FFF2-40B4-BE49-F238E27FC236}">
-                <a16:creationId xmlns:a16="http://schemas.microsoft.com/office/drawing/2014/main" id="{9BF326DF-36AA-4AE7-8DF3-524803DD1E19}"/>
+                <a16:creationId xmlns:a16="http://schemas.microsoft.com/office/drawing/2014/main" id="{1428C657-D16C-413F-8827-42E6C74FF699}"/>
               </a:ext>
             </a:extLst>
           </p:cNvPr>
@@ -5643,7 +5643,7 @@
           <p:cNvPr id="5" name="">
             <a:extLst xmlns:a="http://schemas.openxmlformats.org/drawingml/2006/main">
               <a:ext uri="{FF2B5EF4-FFF2-40B4-BE49-F238E27FC236}">
-                <a16:creationId xmlns:a16="http://schemas.microsoft.com/office/drawing/2014/main" id="{C272B474-6527-4513-AA73-BF05A0B96667}"/>
+                <a16:creationId xmlns:a16="http://schemas.microsoft.com/office/drawing/2014/main" id="{EE74A8BD-B447-43AA-A778-2C260F599941}"/>
               </a:ext>
             </a:extLst>
           </p:cNvPr>
@@ -5693,7 +5693,7 @@
           <p:cNvPr id="6" name="">
             <a:extLst xmlns:a="http://schemas.openxmlformats.org/drawingml/2006/main">
               <a:ext uri="{FF2B5EF4-FFF2-40B4-BE49-F238E27FC236}">
-                <a16:creationId xmlns:a16="http://schemas.microsoft.com/office/drawing/2014/main" id="{5451107A-0226-44D3-9AF6-D767CC09F759}"/>
+                <a16:creationId xmlns:a16="http://schemas.microsoft.com/office/drawing/2014/main" id="{EB97986F-F8D9-4CAE-A49B-3CFB5F45C52B}"/>
               </a:ext>
             </a:extLst>
           </p:cNvPr>
@@ -5743,7 +5743,7 @@
           <p:cNvPr id="7" name="">
             <a:extLst xmlns:a="http://schemas.openxmlformats.org/drawingml/2006/main">
               <a:ext uri="{FF2B5EF4-FFF2-40B4-BE49-F238E27FC236}">
-                <a16:creationId xmlns:a16="http://schemas.microsoft.com/office/drawing/2014/main" id="{F3AA8DF5-94AD-434B-99CE-EBC301AC104A}"/>
+                <a16:creationId xmlns:a16="http://schemas.microsoft.com/office/drawing/2014/main" id="{F7EFA877-B219-4BEB-9E92-143C56D6D43B}"/>
               </a:ext>
             </a:extLst>
           </p:cNvPr>
@@ -5793,7 +5793,7 @@
           <p:cNvPr id="8" name="">
             <a:extLst xmlns:a="http://schemas.openxmlformats.org/drawingml/2006/main">
               <a:ext uri="{FF2B5EF4-FFF2-40B4-BE49-F238E27FC236}">
-                <a16:creationId xmlns:a16="http://schemas.microsoft.com/office/drawing/2014/main" id="{248EF573-B1D7-47D4-B46C-77CE33365C6A}"/>
+                <a16:creationId xmlns:a16="http://schemas.microsoft.com/office/drawing/2014/main" id="{1CCDDFD9-4101-4213-8313-15CA2CA4C797}"/>
               </a:ext>
             </a:extLst>
           </p:cNvPr>
@@ -5828,7 +5828,7 @@
           <p:cNvPr id="9" name="">
             <a:extLst xmlns:a="http://schemas.openxmlformats.org/drawingml/2006/main">
               <a:ext uri="{FF2B5EF4-FFF2-40B4-BE49-F238E27FC236}">
-                <a16:creationId xmlns:a16="http://schemas.microsoft.com/office/drawing/2014/main" id="{DC5182B3-A9FE-4E28-8033-4D148039C8B1}"/>
+                <a16:creationId xmlns:a16="http://schemas.microsoft.com/office/drawing/2014/main" id="{369A61E2-CFEE-429E-B2AE-99E6C26653D0}"/>
               </a:ext>
             </a:extLst>
           </p:cNvPr>
@@ -5878,7 +5878,7 @@
           <p:cNvPr id="10" name="">
             <a:extLst xmlns:a="http://schemas.openxmlformats.org/drawingml/2006/main">
               <a:ext uri="{FF2B5EF4-FFF2-40B4-BE49-F238E27FC236}">
-                <a16:creationId xmlns:a16="http://schemas.microsoft.com/office/drawing/2014/main" id="{D7CFDAE5-723C-4673-966D-5B27F5547B85}"/>
+                <a16:creationId xmlns:a16="http://schemas.microsoft.com/office/drawing/2014/main" id="{C7A93B6B-DB87-4E88-A703-C8D2158398E6}"/>
               </a:ext>
             </a:extLst>
           </p:cNvPr>
@@ -5928,7 +5928,7 @@
           <p:cNvPr id="11" name="">
             <a:extLst xmlns:a="http://schemas.openxmlformats.org/drawingml/2006/main">
               <a:ext uri="{FF2B5EF4-FFF2-40B4-BE49-F238E27FC236}">
-                <a16:creationId xmlns:a16="http://schemas.microsoft.com/office/drawing/2014/main" id="{C3A1AB35-F92A-40C3-AA38-700C36C7A284}"/>
+                <a16:creationId xmlns:a16="http://schemas.microsoft.com/office/drawing/2014/main" id="{A31747F0-61ED-4DC1-82C3-AE7C11B9D0FA}"/>
               </a:ext>
             </a:extLst>
           </p:cNvPr>
@@ -5978,7 +5978,7 @@
           <p:cNvPr id="12" name="">
             <a:extLst xmlns:a="http://schemas.openxmlformats.org/drawingml/2006/main">
               <a:ext uri="{FF2B5EF4-FFF2-40B4-BE49-F238E27FC236}">
-                <a16:creationId xmlns:a16="http://schemas.microsoft.com/office/drawing/2014/main" id="{D69FB3BB-8D9D-4B7B-B0E7-312AABF003BF}"/>
+                <a16:creationId xmlns:a16="http://schemas.microsoft.com/office/drawing/2014/main" id="{9AA3858B-EA48-4CBE-AA9E-4BFD68BF7EB1}"/>
               </a:ext>
             </a:extLst>
           </p:cNvPr>
@@ -6028,7 +6028,7 @@
           <p:cNvPr id="13" name="">
             <a:extLst xmlns:a="http://schemas.openxmlformats.org/drawingml/2006/main">
               <a:ext uri="{FF2B5EF4-FFF2-40B4-BE49-F238E27FC236}">
-                <a16:creationId xmlns:a16="http://schemas.microsoft.com/office/drawing/2014/main" id="{7F3A432C-16F2-46F6-B535-48FFFF0ADE27}"/>
+                <a16:creationId xmlns:a16="http://schemas.microsoft.com/office/drawing/2014/main" id="{26CD1764-0637-4D46-A362-572842D61DC4}"/>
               </a:ext>
             </a:extLst>
           </p:cNvPr>
@@ -6063,7 +6063,7 @@
           <p:cNvPr id="14" name="">
             <a:extLst xmlns:a="http://schemas.openxmlformats.org/drawingml/2006/main">
               <a:ext uri="{FF2B5EF4-FFF2-40B4-BE49-F238E27FC236}">
-                <a16:creationId xmlns:a16="http://schemas.microsoft.com/office/drawing/2014/main" id="{06E8837A-00A4-49C6-9200-79CE499E35B6}"/>
+                <a16:creationId xmlns:a16="http://schemas.microsoft.com/office/drawing/2014/main" id="{303E692F-980A-48FB-9338-F3BFD1892BC3}"/>
               </a:ext>
             </a:extLst>
           </p:cNvPr>
@@ -6113,7 +6113,7 @@
           <p:cNvPr id="15" name="">
             <a:extLst xmlns:a="http://schemas.openxmlformats.org/drawingml/2006/main">
               <a:ext uri="{FF2B5EF4-FFF2-40B4-BE49-F238E27FC236}">
-                <a16:creationId xmlns:a16="http://schemas.microsoft.com/office/drawing/2014/main" id="{F873A7DB-5C63-4C7A-B6C0-C61D549ECDDA}"/>
+                <a16:creationId xmlns:a16="http://schemas.microsoft.com/office/drawing/2014/main" id="{AEA2EA33-B8D2-4DFC-9E8C-865201F490AF}"/>
               </a:ext>
             </a:extLst>
           </p:cNvPr>
@@ -6163,7 +6163,7 @@
           <p:cNvPr id="16" name="">
             <a:extLst xmlns:a="http://schemas.openxmlformats.org/drawingml/2006/main">
               <a:ext uri="{FF2B5EF4-FFF2-40B4-BE49-F238E27FC236}">
-                <a16:creationId xmlns:a16="http://schemas.microsoft.com/office/drawing/2014/main" id="{926BDFE6-F9D1-4225-A617-F741F956A91B}"/>
+                <a16:creationId xmlns:a16="http://schemas.microsoft.com/office/drawing/2014/main" id="{99EF3D4E-A740-4DCD-AD6F-437CCBFDFC21}"/>
               </a:ext>
             </a:extLst>
           </p:cNvPr>
@@ -6213,7 +6213,7 @@
           <p:cNvPr id="17" name="">
             <a:extLst xmlns:a="http://schemas.openxmlformats.org/drawingml/2006/main">
               <a:ext uri="{FF2B5EF4-FFF2-40B4-BE49-F238E27FC236}">
-                <a16:creationId xmlns:a16="http://schemas.microsoft.com/office/drawing/2014/main" id="{C4EBC002-2110-46B9-BFCB-983AC05762DF}"/>
+                <a16:creationId xmlns:a16="http://schemas.microsoft.com/office/drawing/2014/main" id="{7595B331-3BCD-4156-B43E-58F6CEFBD44A}"/>
               </a:ext>
             </a:extLst>
           </p:cNvPr>
@@ -6263,7 +6263,7 @@
           <p:cNvPr id="18" name="">
             <a:extLst xmlns:a="http://schemas.openxmlformats.org/drawingml/2006/main">
               <a:ext uri="{FF2B5EF4-FFF2-40B4-BE49-F238E27FC236}">
-                <a16:creationId xmlns:a16="http://schemas.microsoft.com/office/drawing/2014/main" id="{6DAFAAE9-4844-41D8-96EF-D138F3B4E553}"/>
+                <a16:creationId xmlns:a16="http://schemas.microsoft.com/office/drawing/2014/main" id="{1FC7F13F-2BAD-4410-810B-E7B649F339E4}"/>
               </a:ext>
             </a:extLst>
           </p:cNvPr>
@@ -6298,7 +6298,7 @@
           <p:cNvPr id="19" name="">
             <a:extLst xmlns:a="http://schemas.openxmlformats.org/drawingml/2006/main">
               <a:ext uri="{FF2B5EF4-FFF2-40B4-BE49-F238E27FC236}">
-                <a16:creationId xmlns:a16="http://schemas.microsoft.com/office/drawing/2014/main" id="{846F747F-D780-4A21-A3F5-A131C7B9FC32}"/>
+                <a16:creationId xmlns:a16="http://schemas.microsoft.com/office/drawing/2014/main" id="{0D147914-CB39-442C-845E-BD95FD62F7AF}"/>
               </a:ext>
             </a:extLst>
           </p:cNvPr>
@@ -6348,7 +6348,7 @@
           <p:cNvPr id="20" name="">
             <a:extLst xmlns:a="http://schemas.openxmlformats.org/drawingml/2006/main">
               <a:ext uri="{FF2B5EF4-FFF2-40B4-BE49-F238E27FC236}">
-                <a16:creationId xmlns:a16="http://schemas.microsoft.com/office/drawing/2014/main" id="{F678E961-10BA-42F2-9FF3-54A06827F394}"/>
+                <a16:creationId xmlns:a16="http://schemas.microsoft.com/office/drawing/2014/main" id="{B77B3A59-EC7F-4A84-B9B8-E6335111F4E4}"/>
               </a:ext>
             </a:extLst>
           </p:cNvPr>
@@ -6398,7 +6398,7 @@
           <p:cNvPr id="21" name="">
             <a:extLst xmlns:a="http://schemas.openxmlformats.org/drawingml/2006/main">
               <a:ext uri="{FF2B5EF4-FFF2-40B4-BE49-F238E27FC236}">
-                <a16:creationId xmlns:a16="http://schemas.microsoft.com/office/drawing/2014/main" id="{59084CE4-EF1E-463C-A05E-238498C952F8}"/>
+                <a16:creationId xmlns:a16="http://schemas.microsoft.com/office/drawing/2014/main" id="{5E9B1DA5-C220-42AD-90ED-93AA7D951ED4}"/>
               </a:ext>
             </a:extLst>
           </p:cNvPr>
@@ -6448,7 +6448,7 @@
           <p:cNvPr id="22" name="">
             <a:extLst xmlns:a="http://schemas.openxmlformats.org/drawingml/2006/main">
               <a:ext uri="{FF2B5EF4-FFF2-40B4-BE49-F238E27FC236}">
-                <a16:creationId xmlns:a16="http://schemas.microsoft.com/office/drawing/2014/main" id="{7444E665-24BA-4ABA-AF99-AF88EC45DAC7}"/>
+                <a16:creationId xmlns:a16="http://schemas.microsoft.com/office/drawing/2014/main" id="{B628A267-7BF5-41C0-B7B0-8FBE24B36545}"/>
               </a:ext>
             </a:extLst>
           </p:cNvPr>
@@ -6498,7 +6498,7 @@
           <p:cNvPr id="23" name="">
             <a:extLst xmlns:a="http://schemas.openxmlformats.org/drawingml/2006/main">
               <a:ext uri="{FF2B5EF4-FFF2-40B4-BE49-F238E27FC236}">
-                <a16:creationId xmlns:a16="http://schemas.microsoft.com/office/drawing/2014/main" id="{84FC70AC-5393-40B7-8B1E-CF263BF83E1A}"/>
+                <a16:creationId xmlns:a16="http://schemas.microsoft.com/office/drawing/2014/main" id="{63D8BDB3-5EDA-4DFE-9CC5-BDDACFD969CE}"/>
               </a:ext>
             </a:extLst>
           </p:cNvPr>
@@ -6533,7 +6533,7 @@
           <p:cNvPr id="24" name="">
             <a:extLst xmlns:a="http://schemas.openxmlformats.org/drawingml/2006/main">
               <a:ext uri="{FF2B5EF4-FFF2-40B4-BE49-F238E27FC236}">
-                <a16:creationId xmlns:a16="http://schemas.microsoft.com/office/drawing/2014/main" id="{9665B619-7F0A-4842-963A-3E204DEDFE7B}"/>
+                <a16:creationId xmlns:a16="http://schemas.microsoft.com/office/drawing/2014/main" id="{248B4324-EC57-4C32-BCC8-B46E693F51AB}"/>
               </a:ext>
             </a:extLst>
           </p:cNvPr>
@@ -6583,7 +6583,7 @@
           <p:cNvPr id="25" name="">
             <a:extLst xmlns:a="http://schemas.openxmlformats.org/drawingml/2006/main">
               <a:ext uri="{FF2B5EF4-FFF2-40B4-BE49-F238E27FC236}">
-                <a16:creationId xmlns:a16="http://schemas.microsoft.com/office/drawing/2014/main" id="{0B1A7D24-5AB0-4AE0-B32D-A5E720307EB0}"/>
+                <a16:creationId xmlns:a16="http://schemas.microsoft.com/office/drawing/2014/main" id="{62E845B4-23E5-4694-95F4-31EA25A614E6}"/>
               </a:ext>
             </a:extLst>
           </p:cNvPr>
@@ -6633,7 +6633,7 @@
           <p:cNvPr id="26" name="">
             <a:extLst xmlns:a="http://schemas.openxmlformats.org/drawingml/2006/main">
               <a:ext uri="{FF2B5EF4-FFF2-40B4-BE49-F238E27FC236}">
-                <a16:creationId xmlns:a16="http://schemas.microsoft.com/office/drawing/2014/main" id="{76A97B3E-1AA8-427A-A4D2-543FD24A4A61}"/>
+                <a16:creationId xmlns:a16="http://schemas.microsoft.com/office/drawing/2014/main" id="{392DF109-3AB7-4F7B-86F8-7D5499C4B643}"/>
               </a:ext>
             </a:extLst>
           </p:cNvPr>
@@ -6683,7 +6683,7 @@
           <p:cNvPr id="27" name="">
             <a:extLst xmlns:a="http://schemas.openxmlformats.org/drawingml/2006/main">
               <a:ext uri="{FF2B5EF4-FFF2-40B4-BE49-F238E27FC236}">
-                <a16:creationId xmlns:a16="http://schemas.microsoft.com/office/drawing/2014/main" id="{DC5D3444-91FD-44C6-AB15-15747CDAD419}"/>
+                <a16:creationId xmlns:a16="http://schemas.microsoft.com/office/drawing/2014/main" id="{95DE13EE-9BBC-43B6-AF56-7D8D753A0245}"/>
               </a:ext>
             </a:extLst>
           </p:cNvPr>
@@ -6731,7 +6731,7 @@
     </p:spTree>
     <p:extLst>
       <p:ext uri="{BB962C8B-B14F-4D97-AF65-F5344CB8AC3E}">
-        <p14:creationId xmlns:p14="http://schemas.microsoft.com/office/powerpoint/2010/main" val="1006363226"/>
+        <p14:creationId xmlns:p14="http://schemas.microsoft.com/office/powerpoint/2010/main" val="827571556"/>
       </p:ext>
     </p:extLst>
   </p:cSld>
@@ -6762,7 +6762,7 @@
           <p:cNvPr id="20" name="">
             <a:extLst xmlns:a="http://schemas.openxmlformats.org/drawingml/2006/main">
               <a:ext uri="{FF2B5EF4-FFF2-40B4-BE49-F238E27FC236}">
-                <a16:creationId xmlns:a16="http://schemas.microsoft.com/office/drawing/2014/main" id="{C01F99E7-2A68-40A6-AD70-38F1C2B6D47E}"/>
+                <a16:creationId xmlns:a16="http://schemas.microsoft.com/office/drawing/2014/main" id="{88DCCF5F-9353-4C96-AD8F-A8E264B552B7}"/>
               </a:ext>
             </a:extLst>
           </p:cNvPr>
@@ -6812,7 +6812,7 @@
           <p:cNvPr id="2" name="">
             <a:extLst xmlns:a="http://schemas.openxmlformats.org/drawingml/2006/main">
               <a:ext uri="{FF2B5EF4-FFF2-40B4-BE49-F238E27FC236}">
-                <a16:creationId xmlns:a16="http://schemas.microsoft.com/office/drawing/2014/main" id="{2C9BE654-8B6C-496A-9A9F-ECDC2E32E6B0}"/>
+                <a16:creationId xmlns:a16="http://schemas.microsoft.com/office/drawing/2014/main" id="{7F614487-9622-470A-89CD-3CA1DB6B0848}"/>
               </a:ext>
             </a:extLst>
           </p:cNvPr>
@@ -6862,7 +6862,7 @@
           <p:cNvPr id="3" name="">
             <a:extLst xmlns:a="http://schemas.openxmlformats.org/drawingml/2006/main">
               <a:ext uri="{FF2B5EF4-FFF2-40B4-BE49-F238E27FC236}">
-                <a16:creationId xmlns:a16="http://schemas.microsoft.com/office/drawing/2014/main" id="{9943A27D-03CB-425E-B421-7831563AC451}"/>
+                <a16:creationId xmlns:a16="http://schemas.microsoft.com/office/drawing/2014/main" id="{94E43F94-68A0-4A4A-8D08-DE883627131D}"/>
               </a:ext>
             </a:extLst>
           </p:cNvPr>
@@ -6893,7 +6893,7 @@
           <p:cNvPr id="4" name="">
             <a:extLst xmlns:a="http://schemas.openxmlformats.org/drawingml/2006/main">
               <a:ext uri="{FF2B5EF4-FFF2-40B4-BE49-F238E27FC236}">
-                <a16:creationId xmlns:a16="http://schemas.microsoft.com/office/drawing/2014/main" id="{EA3D7EE6-849F-4652-92CA-6E648FCCBC6B}"/>
+                <a16:creationId xmlns:a16="http://schemas.microsoft.com/office/drawing/2014/main" id="{C5187E55-C1AC-4F35-B02D-C27A506E9048}"/>
               </a:ext>
             </a:extLst>
           </p:cNvPr>
@@ -6943,7 +6943,7 @@
           <p:cNvPr id="5" name="">
             <a:extLst xmlns:a="http://schemas.openxmlformats.org/drawingml/2006/main">
               <a:ext uri="{FF2B5EF4-FFF2-40B4-BE49-F238E27FC236}">
-                <a16:creationId xmlns:a16="http://schemas.microsoft.com/office/drawing/2014/main" id="{D43D5585-7D5F-4027-851E-DE689B16A608}"/>
+                <a16:creationId xmlns:a16="http://schemas.microsoft.com/office/drawing/2014/main" id="{2465F4CF-5FBC-4A77-9F94-20F4201AC7DC}"/>
               </a:ext>
             </a:extLst>
           </p:cNvPr>
@@ -6993,7 +6993,7 @@
           <p:cNvPr id="6" name="">
             <a:extLst xmlns:a="http://schemas.openxmlformats.org/drawingml/2006/main">
               <a:ext uri="{FF2B5EF4-FFF2-40B4-BE49-F238E27FC236}">
-                <a16:creationId xmlns:a16="http://schemas.microsoft.com/office/drawing/2014/main" id="{C4516FA9-E51D-4B76-B2D0-D89B4CD96257}"/>
+                <a16:creationId xmlns:a16="http://schemas.microsoft.com/office/drawing/2014/main" id="{D79E5DCB-9F15-4BB5-949D-F707BF640648}"/>
               </a:ext>
             </a:extLst>
           </p:cNvPr>
@@ -7043,7 +7043,7 @@
           <p:cNvPr id="7" name="">
             <a:extLst xmlns:a="http://schemas.openxmlformats.org/drawingml/2006/main">
               <a:ext uri="{FF2B5EF4-FFF2-40B4-BE49-F238E27FC236}">
-                <a16:creationId xmlns:a16="http://schemas.microsoft.com/office/drawing/2014/main" id="{642DFB34-EBAD-43F8-8E5C-5EAC5F27974C}"/>
+                <a16:creationId xmlns:a16="http://schemas.microsoft.com/office/drawing/2014/main" id="{4A9875A3-0A9E-49CF-82EA-59341B1F1DE7}"/>
               </a:ext>
             </a:extLst>
           </p:cNvPr>
@@ -7093,7 +7093,7 @@
           <p:cNvPr id="8" name="">
             <a:extLst xmlns:a="http://schemas.openxmlformats.org/drawingml/2006/main">
               <a:ext uri="{FF2B5EF4-FFF2-40B4-BE49-F238E27FC236}">
-                <a16:creationId xmlns:a16="http://schemas.microsoft.com/office/drawing/2014/main" id="{6FD54F79-2951-4BA8-A861-75696F2954AF}"/>
+                <a16:creationId xmlns:a16="http://schemas.microsoft.com/office/drawing/2014/main" id="{684EB6B1-E27B-427A-B6A8-217002613411}"/>
               </a:ext>
             </a:extLst>
           </p:cNvPr>
@@ -7124,7 +7124,7 @@
           <p:cNvPr id="9" name="">
             <a:extLst xmlns:a="http://schemas.openxmlformats.org/drawingml/2006/main">
               <a:ext uri="{FF2B5EF4-FFF2-40B4-BE49-F238E27FC236}">
-                <a16:creationId xmlns:a16="http://schemas.microsoft.com/office/drawing/2014/main" id="{0FE0A1FE-AF25-4B14-B049-7D6FAAE6D0FC}"/>
+                <a16:creationId xmlns:a16="http://schemas.microsoft.com/office/drawing/2014/main" id="{E75C5465-12B0-4E25-AC2A-08A687E0D579}"/>
               </a:ext>
             </a:extLst>
           </p:cNvPr>
@@ -7174,7 +7174,7 @@
           <p:cNvPr id="10" name="">
             <a:extLst xmlns:a="http://schemas.openxmlformats.org/drawingml/2006/main">
               <a:ext uri="{FF2B5EF4-FFF2-40B4-BE49-F238E27FC236}">
-                <a16:creationId xmlns:a16="http://schemas.microsoft.com/office/drawing/2014/main" id="{9B9C48F4-EFD9-42E1-8570-6F2AC7524AE7}"/>
+                <a16:creationId xmlns:a16="http://schemas.microsoft.com/office/drawing/2014/main" id="{C807BC33-239B-43A4-8C8A-83DA6473D5D8}"/>
               </a:ext>
             </a:extLst>
           </p:cNvPr>
@@ -7224,7 +7224,7 @@
           <p:cNvPr id="11" name="">
             <a:extLst xmlns:a="http://schemas.openxmlformats.org/drawingml/2006/main">
               <a:ext uri="{FF2B5EF4-FFF2-40B4-BE49-F238E27FC236}">
-                <a16:creationId xmlns:a16="http://schemas.microsoft.com/office/drawing/2014/main" id="{97B8F8EA-531E-46E0-9E91-3F13D70EB2F1}"/>
+                <a16:creationId xmlns:a16="http://schemas.microsoft.com/office/drawing/2014/main" id="{412499AE-455B-47EC-BF95-3FF5FC16B311}"/>
               </a:ext>
             </a:extLst>
           </p:cNvPr>
@@ -7255,7 +7255,7 @@
           <p:cNvPr id="12" name="">
             <a:extLst xmlns:a="http://schemas.openxmlformats.org/drawingml/2006/main">
               <a:ext uri="{FF2B5EF4-FFF2-40B4-BE49-F238E27FC236}">
-                <a16:creationId xmlns:a16="http://schemas.microsoft.com/office/drawing/2014/main" id="{F9055D5E-C9FA-4C2C-9450-946F9E31BB16}"/>
+                <a16:creationId xmlns:a16="http://schemas.microsoft.com/office/drawing/2014/main" id="{FA48F90C-A233-48A2-8EF1-045CF23671ED}"/>
               </a:ext>
             </a:extLst>
           </p:cNvPr>
@@ -7305,7 +7305,7 @@
           <p:cNvPr id="13" name="">
             <a:extLst xmlns:a="http://schemas.openxmlformats.org/drawingml/2006/main">
               <a:ext uri="{FF2B5EF4-FFF2-40B4-BE49-F238E27FC236}">
-                <a16:creationId xmlns:a16="http://schemas.microsoft.com/office/drawing/2014/main" id="{AE502BBA-28FA-4BE7-91E4-A8B8B1C78310}"/>
+                <a16:creationId xmlns:a16="http://schemas.microsoft.com/office/drawing/2014/main" id="{1867F687-18A1-4898-AE62-8A6B885326D1}"/>
               </a:ext>
             </a:extLst>
           </p:cNvPr>
@@ -7355,7 +7355,7 @@
           <p:cNvPr id="14" name="">
             <a:extLst xmlns:a="http://schemas.openxmlformats.org/drawingml/2006/main">
               <a:ext uri="{FF2B5EF4-FFF2-40B4-BE49-F238E27FC236}">
-                <a16:creationId xmlns:a16="http://schemas.microsoft.com/office/drawing/2014/main" id="{E7C39901-F628-4EB5-A903-FC63671619ED}"/>
+                <a16:creationId xmlns:a16="http://schemas.microsoft.com/office/drawing/2014/main" id="{DE790042-AE56-4BE3-B902-FEF238FC721D}"/>
               </a:ext>
             </a:extLst>
           </p:cNvPr>
@@ -7386,7 +7386,7 @@
           <p:cNvPr id="15" name="">
             <a:extLst xmlns:a="http://schemas.openxmlformats.org/drawingml/2006/main">
               <a:ext uri="{FF2B5EF4-FFF2-40B4-BE49-F238E27FC236}">
-                <a16:creationId xmlns:a16="http://schemas.microsoft.com/office/drawing/2014/main" id="{F76671BA-4CCC-4636-A48A-8A984242D96E}"/>
+                <a16:creationId xmlns:a16="http://schemas.microsoft.com/office/drawing/2014/main" id="{078376EC-D7AA-4B96-A644-8FAD26F64B2B}"/>
               </a:ext>
             </a:extLst>
           </p:cNvPr>
@@ -7436,7 +7436,7 @@
           <p:cNvPr id="16" name="">
             <a:extLst xmlns:a="http://schemas.openxmlformats.org/drawingml/2006/main">
               <a:ext uri="{FF2B5EF4-FFF2-40B4-BE49-F238E27FC236}">
-                <a16:creationId xmlns:a16="http://schemas.microsoft.com/office/drawing/2014/main" id="{C830E937-A5C1-4F5D-AB7E-467830DB6A26}"/>
+                <a16:creationId xmlns:a16="http://schemas.microsoft.com/office/drawing/2014/main" id="{8D8D571B-8E80-457E-8FA9-2428E3EE088B}"/>
               </a:ext>
             </a:extLst>
           </p:cNvPr>
@@ -7486,7 +7486,7 @@
           <p:cNvPr id="17" name="">
             <a:extLst xmlns:a="http://schemas.openxmlformats.org/drawingml/2006/main">
               <a:ext uri="{FF2B5EF4-FFF2-40B4-BE49-F238E27FC236}">
-                <a16:creationId xmlns:a16="http://schemas.microsoft.com/office/drawing/2014/main" id="{35886BD8-2C60-4A6F-9BF0-C923A8A43E6F}"/>
+                <a16:creationId xmlns:a16="http://schemas.microsoft.com/office/drawing/2014/main" id="{3A3E581F-5810-4F9B-AEBC-8014E10473ED}"/>
               </a:ext>
             </a:extLst>
           </p:cNvPr>
@@ -7517,7 +7517,7 @@
           <p:cNvPr id="18" name="">
             <a:extLst xmlns:a="http://schemas.openxmlformats.org/drawingml/2006/main">
               <a:ext uri="{FF2B5EF4-FFF2-40B4-BE49-F238E27FC236}">
-                <a16:creationId xmlns:a16="http://schemas.microsoft.com/office/drawing/2014/main" id="{D743256E-44BF-4111-94D8-DD1AE13E6450}"/>
+                <a16:creationId xmlns:a16="http://schemas.microsoft.com/office/drawing/2014/main" id="{CD4D8611-D76E-4251-9A49-647440621AB7}"/>
               </a:ext>
             </a:extLst>
           </p:cNvPr>
@@ -7567,7 +7567,7 @@
           <p:cNvPr id="19" name="">
             <a:extLst xmlns:a="http://schemas.openxmlformats.org/drawingml/2006/main">
               <a:ext uri="{FF2B5EF4-FFF2-40B4-BE49-F238E27FC236}">
-                <a16:creationId xmlns:a16="http://schemas.microsoft.com/office/drawing/2014/main" id="{E0DA6DDC-299D-4BFE-B47A-0445689621AD}"/>
+                <a16:creationId xmlns:a16="http://schemas.microsoft.com/office/drawing/2014/main" id="{051BCD5D-A101-43E7-871A-FBBF683DCB68}"/>
               </a:ext>
             </a:extLst>
           </p:cNvPr>
@@ -7615,7 +7615,7 @@
     </p:spTree>
     <p:extLst>
       <p:ext uri="{BB962C8B-B14F-4D97-AF65-F5344CB8AC3E}">
-        <p14:creationId xmlns:p14="http://schemas.microsoft.com/office/powerpoint/2010/main" val="498122267"/>
+        <p14:creationId xmlns:p14="http://schemas.microsoft.com/office/powerpoint/2010/main" val="144571954"/>
       </p:ext>
     </p:extLst>
   </p:cSld>
@@ -7646,7 +7646,7 @@
           <p:cNvPr id="44" name="">
             <a:extLst xmlns:a="http://schemas.openxmlformats.org/drawingml/2006/main">
               <a:ext uri="{FF2B5EF4-FFF2-40B4-BE49-F238E27FC236}">
-                <a16:creationId xmlns:a16="http://schemas.microsoft.com/office/drawing/2014/main" id="{3372E559-7FC3-4DD0-B1B4-CD565D5578BC}"/>
+                <a16:creationId xmlns:a16="http://schemas.microsoft.com/office/drawing/2014/main" id="{7F2A6AE4-10CA-44A7-B126-357A0DCE4B27}"/>
               </a:ext>
             </a:extLst>
           </p:cNvPr>
@@ -7696,7 +7696,7 @@
           <p:cNvPr id="2" name="">
             <a:extLst xmlns:a="http://schemas.openxmlformats.org/drawingml/2006/main">
               <a:ext uri="{FF2B5EF4-FFF2-40B4-BE49-F238E27FC236}">
-                <a16:creationId xmlns:a16="http://schemas.microsoft.com/office/drawing/2014/main" id="{DB22966A-3B34-40E9-95BE-2CAF794B71FB}"/>
+                <a16:creationId xmlns:a16="http://schemas.microsoft.com/office/drawing/2014/main" id="{4B183229-DB1F-4BF6-B116-BE065BFECCB3}"/>
               </a:ext>
             </a:extLst>
           </p:cNvPr>
@@ -7746,7 +7746,7 @@
           <p:cNvPr id="3" name="">
             <a:extLst xmlns:a="http://schemas.openxmlformats.org/drawingml/2006/main">
               <a:ext uri="{FF2B5EF4-FFF2-40B4-BE49-F238E27FC236}">
-                <a16:creationId xmlns:a16="http://schemas.microsoft.com/office/drawing/2014/main" id="{3F766EAE-508D-4208-8C2B-46353A03CE8A}"/>
+                <a16:creationId xmlns:a16="http://schemas.microsoft.com/office/drawing/2014/main" id="{BD4FF8A9-BC23-469B-822E-9207836299EF}"/>
               </a:ext>
             </a:extLst>
           </p:cNvPr>
@@ -7777,7 +7777,7 @@
           <p:cNvPr id="4" name="">
             <a:extLst xmlns:a="http://schemas.openxmlformats.org/drawingml/2006/main">
               <a:ext uri="{FF2B5EF4-FFF2-40B4-BE49-F238E27FC236}">
-                <a16:creationId xmlns:a16="http://schemas.microsoft.com/office/drawing/2014/main" id="{F469BC7F-6178-4295-8CD6-A7F3AF4D4292}"/>
+                <a16:creationId xmlns:a16="http://schemas.microsoft.com/office/drawing/2014/main" id="{25ED64B5-FD6A-4B05-91E4-EAC2E8C72B6D}"/>
               </a:ext>
             </a:extLst>
           </p:cNvPr>
@@ -7827,7 +7827,7 @@
           <p:cNvPr id="5" name="">
             <a:extLst xmlns:a="http://schemas.openxmlformats.org/drawingml/2006/main">
               <a:ext uri="{FF2B5EF4-FFF2-40B4-BE49-F238E27FC236}">
-                <a16:creationId xmlns:a16="http://schemas.microsoft.com/office/drawing/2014/main" id="{8349BFDD-487C-45C9-B2D2-5B5A3EEF1D49}"/>
+                <a16:creationId xmlns:a16="http://schemas.microsoft.com/office/drawing/2014/main" id="{46973CCC-56EE-4FA2-92E6-F229CEAC5C81}"/>
               </a:ext>
             </a:extLst>
           </p:cNvPr>
@@ -7877,7 +7877,7 @@
           <p:cNvPr id="6" name="">
             <a:extLst xmlns:a="http://schemas.openxmlformats.org/drawingml/2006/main">
               <a:ext uri="{FF2B5EF4-FFF2-40B4-BE49-F238E27FC236}">
-                <a16:creationId xmlns:a16="http://schemas.microsoft.com/office/drawing/2014/main" id="{27B4CC9F-0715-4E10-8B74-21FF122270F6}"/>
+                <a16:creationId xmlns:a16="http://schemas.microsoft.com/office/drawing/2014/main" id="{EEBDA2C2-ED47-4372-9375-D8943474F692}"/>
               </a:ext>
             </a:extLst>
           </p:cNvPr>
@@ -7927,7 +7927,7 @@
           <p:cNvPr id="7" name="">
             <a:extLst xmlns:a="http://schemas.openxmlformats.org/drawingml/2006/main">
               <a:ext uri="{FF2B5EF4-FFF2-40B4-BE49-F238E27FC236}">
-                <a16:creationId xmlns:a16="http://schemas.microsoft.com/office/drawing/2014/main" id="{A95FBB3B-3C9C-455D-B8DA-3105A747810B}"/>
+                <a16:creationId xmlns:a16="http://schemas.microsoft.com/office/drawing/2014/main" id="{711B33FF-62AF-4118-A04F-DCFB1B52CD37}"/>
               </a:ext>
             </a:extLst>
           </p:cNvPr>
@@ -7977,7 +7977,7 @@
           <p:cNvPr id="8" name="">
             <a:extLst xmlns:a="http://schemas.openxmlformats.org/drawingml/2006/main">
               <a:ext uri="{FF2B5EF4-FFF2-40B4-BE49-F238E27FC236}">
-                <a16:creationId xmlns:a16="http://schemas.microsoft.com/office/drawing/2014/main" id="{F2597623-5516-4161-AFBF-8B192D9AA929}"/>
+                <a16:creationId xmlns:a16="http://schemas.microsoft.com/office/drawing/2014/main" id="{B7111963-824F-4EE6-A547-27C3CC3C940C}"/>
               </a:ext>
             </a:extLst>
           </p:cNvPr>
@@ -8008,7 +8008,7 @@
           <p:cNvPr id="9" name="">
             <a:extLst xmlns:a="http://schemas.openxmlformats.org/drawingml/2006/main">
               <a:ext uri="{FF2B5EF4-FFF2-40B4-BE49-F238E27FC236}">
-                <a16:creationId xmlns:a16="http://schemas.microsoft.com/office/drawing/2014/main" id="{194A75C4-F180-4AFC-A851-4328361AA98C}"/>
+                <a16:creationId xmlns:a16="http://schemas.microsoft.com/office/drawing/2014/main" id="{7D6ED08B-705D-47CB-8D22-EC6EE329ED3A}"/>
               </a:ext>
             </a:extLst>
           </p:cNvPr>
@@ -8058,7 +8058,7 @@
           <p:cNvPr id="10" name="">
             <a:extLst xmlns:a="http://schemas.openxmlformats.org/drawingml/2006/main">
               <a:ext uri="{FF2B5EF4-FFF2-40B4-BE49-F238E27FC236}">
-                <a16:creationId xmlns:a16="http://schemas.microsoft.com/office/drawing/2014/main" id="{C09B7B68-ED4A-4BD2-BD7A-7726868BE12B}"/>
+                <a16:creationId xmlns:a16="http://schemas.microsoft.com/office/drawing/2014/main" id="{80F3E07E-656D-450D-A4AF-1153D2A99D06}"/>
               </a:ext>
             </a:extLst>
           </p:cNvPr>
@@ -8089,7 +8089,7 @@
           <p:cNvPr id="11" name="">
             <a:extLst xmlns:a="http://schemas.openxmlformats.org/drawingml/2006/main">
               <a:ext uri="{FF2B5EF4-FFF2-40B4-BE49-F238E27FC236}">
-                <a16:creationId xmlns:a16="http://schemas.microsoft.com/office/drawing/2014/main" id="{BCB4E876-F8F5-4864-BF40-D73A3CDDCB4B}"/>
+                <a16:creationId xmlns:a16="http://schemas.microsoft.com/office/drawing/2014/main" id="{66438756-26BF-40CE-826A-57AC50F3CA03}"/>
               </a:ext>
             </a:extLst>
           </p:cNvPr>
@@ -8139,7 +8139,7 @@
           <p:cNvPr id="12" name="">
             <a:extLst xmlns:a="http://schemas.openxmlformats.org/drawingml/2006/main">
               <a:ext uri="{FF2B5EF4-FFF2-40B4-BE49-F238E27FC236}">
-                <a16:creationId xmlns:a16="http://schemas.microsoft.com/office/drawing/2014/main" id="{07B2A6CC-8298-4DED-A380-F88B5B5A180C}"/>
+                <a16:creationId xmlns:a16="http://schemas.microsoft.com/office/drawing/2014/main" id="{3EE223D6-EE97-4419-B4E6-03EAB0DD8E96}"/>
               </a:ext>
             </a:extLst>
           </p:cNvPr>
@@ -8170,7 +8170,7 @@
           <p:cNvPr id="13" name="">
             <a:extLst xmlns:a="http://schemas.openxmlformats.org/drawingml/2006/main">
               <a:ext uri="{FF2B5EF4-FFF2-40B4-BE49-F238E27FC236}">
-                <a16:creationId xmlns:a16="http://schemas.microsoft.com/office/drawing/2014/main" id="{84C0BE32-0771-4C08-BB73-6AAAC1C5C3CE}"/>
+                <a16:creationId xmlns:a16="http://schemas.microsoft.com/office/drawing/2014/main" id="{6DBE6FB7-54B5-43D1-A06F-D0134E5C12D1}"/>
               </a:ext>
             </a:extLst>
           </p:cNvPr>
@@ -8220,7 +8220,7 @@
           <p:cNvPr id="14" name="">
             <a:extLst xmlns:a="http://schemas.openxmlformats.org/drawingml/2006/main">
               <a:ext uri="{FF2B5EF4-FFF2-40B4-BE49-F238E27FC236}">
-                <a16:creationId xmlns:a16="http://schemas.microsoft.com/office/drawing/2014/main" id="{264251E9-605E-4487-9877-B11A4447CE60}"/>
+                <a16:creationId xmlns:a16="http://schemas.microsoft.com/office/drawing/2014/main" id="{90D7629D-448A-4B8A-945A-E9B36796F09B}"/>
               </a:ext>
             </a:extLst>
           </p:cNvPr>
@@ -8253,7 +8253,7 @@
           <p:cNvPr id="15" name="">
             <a:extLst xmlns:a="http://schemas.openxmlformats.org/drawingml/2006/main">
               <a:ext uri="{FF2B5EF4-FFF2-40B4-BE49-F238E27FC236}">
-                <a16:creationId xmlns:a16="http://schemas.microsoft.com/office/drawing/2014/main" id="{1454A30B-4E97-4DF6-BF9E-1692F6A868B8}"/>
+                <a16:creationId xmlns:a16="http://schemas.microsoft.com/office/drawing/2014/main" id="{3D20D453-BA71-4CCF-B869-A560932579A9}"/>
               </a:ext>
             </a:extLst>
           </p:cNvPr>
@@ -8303,7 +8303,7 @@
           <p:cNvPr id="16" name="">
             <a:extLst xmlns:a="http://schemas.openxmlformats.org/drawingml/2006/main">
               <a:ext uri="{FF2B5EF4-FFF2-40B4-BE49-F238E27FC236}">
-                <a16:creationId xmlns:a16="http://schemas.microsoft.com/office/drawing/2014/main" id="{848B65FF-0C7C-4917-9A7A-2B208D68AB7C}"/>
+                <a16:creationId xmlns:a16="http://schemas.microsoft.com/office/drawing/2014/main" id="{990BE853-9C35-4A75-B9D5-5F6CBEF1B49A}"/>
               </a:ext>
             </a:extLst>
           </p:cNvPr>
@@ -8336,7 +8336,7 @@
           <p:cNvPr id="17" name="">
             <a:extLst xmlns:a="http://schemas.openxmlformats.org/drawingml/2006/main">
               <a:ext uri="{FF2B5EF4-FFF2-40B4-BE49-F238E27FC236}">
-                <a16:creationId xmlns:a16="http://schemas.microsoft.com/office/drawing/2014/main" id="{8BC13888-4589-416A-9426-F79895021AE3}"/>
+                <a16:creationId xmlns:a16="http://schemas.microsoft.com/office/drawing/2014/main" id="{BBFB390B-DA03-4B6D-8C60-EB6EC27B8C57}"/>
               </a:ext>
             </a:extLst>
           </p:cNvPr>
@@ -8386,7 +8386,7 @@
           <p:cNvPr id="18" name="">
             <a:extLst xmlns:a="http://schemas.openxmlformats.org/drawingml/2006/main">
               <a:ext uri="{FF2B5EF4-FFF2-40B4-BE49-F238E27FC236}">
-                <a16:creationId xmlns:a16="http://schemas.microsoft.com/office/drawing/2014/main" id="{2F99DC70-FFCB-48BF-8558-9EEE5474BEC6}"/>
+                <a16:creationId xmlns:a16="http://schemas.microsoft.com/office/drawing/2014/main" id="{0770E81F-5AB1-46D0-9CBE-6D63850E8B12}"/>
               </a:ext>
             </a:extLst>
           </p:cNvPr>
@@ -8419,7 +8419,7 @@
           <p:cNvPr id="19" name="">
             <a:extLst xmlns:a="http://schemas.openxmlformats.org/drawingml/2006/main">
               <a:ext uri="{FF2B5EF4-FFF2-40B4-BE49-F238E27FC236}">
-                <a16:creationId xmlns:a16="http://schemas.microsoft.com/office/drawing/2014/main" id="{EEC3B9DE-CA61-46A1-A0F3-36566EB7BFD5}"/>
+                <a16:creationId xmlns:a16="http://schemas.microsoft.com/office/drawing/2014/main" id="{849FCF3F-C106-4FB5-9EAF-1020405A9F9A}"/>
               </a:ext>
             </a:extLst>
           </p:cNvPr>
@@ -8469,7 +8469,7 @@
           <p:cNvPr id="20" name="">
             <a:extLst xmlns:a="http://schemas.openxmlformats.org/drawingml/2006/main">
               <a:ext uri="{FF2B5EF4-FFF2-40B4-BE49-F238E27FC236}">
-                <a16:creationId xmlns:a16="http://schemas.microsoft.com/office/drawing/2014/main" id="{47C2D84F-E9FE-4E87-BF03-64362BB5584C}"/>
+                <a16:creationId xmlns:a16="http://schemas.microsoft.com/office/drawing/2014/main" id="{9E4B07B8-E294-4ED1-8835-B40823AA34A7}"/>
               </a:ext>
             </a:extLst>
           </p:cNvPr>
@@ -8502,7 +8502,7 @@
           <p:cNvPr id="21" name="">
             <a:extLst xmlns:a="http://schemas.openxmlformats.org/drawingml/2006/main">
               <a:ext uri="{FF2B5EF4-FFF2-40B4-BE49-F238E27FC236}">
-                <a16:creationId xmlns:a16="http://schemas.microsoft.com/office/drawing/2014/main" id="{6DBC9B5B-4C43-456A-A993-917FBA7A5105}"/>
+                <a16:creationId xmlns:a16="http://schemas.microsoft.com/office/drawing/2014/main" id="{1578487E-C9DE-4B0B-BC19-B344503E9036}"/>
               </a:ext>
             </a:extLst>
           </p:cNvPr>
@@ -8552,7 +8552,7 @@
           <p:cNvPr id="22" name="">
             <a:extLst xmlns:a="http://schemas.openxmlformats.org/drawingml/2006/main">
               <a:ext uri="{FF2B5EF4-FFF2-40B4-BE49-F238E27FC236}">
-                <a16:creationId xmlns:a16="http://schemas.microsoft.com/office/drawing/2014/main" id="{44FF23ED-C786-4861-8117-F452ADA9DC2C}"/>
+                <a16:creationId xmlns:a16="http://schemas.microsoft.com/office/drawing/2014/main" id="{6D8EBE49-67C6-4A3D-A192-7DD4E022239A}"/>
               </a:ext>
             </a:extLst>
           </p:cNvPr>
@@ -8585,7 +8585,7 @@
           <p:cNvPr id="23" name="">
             <a:extLst xmlns:a="http://schemas.openxmlformats.org/drawingml/2006/main">
               <a:ext uri="{FF2B5EF4-FFF2-40B4-BE49-F238E27FC236}">
-                <a16:creationId xmlns:a16="http://schemas.microsoft.com/office/drawing/2014/main" id="{8ADBC234-715D-4525-A3AA-63EB7F3DAED1}"/>
+                <a16:creationId xmlns:a16="http://schemas.microsoft.com/office/drawing/2014/main" id="{D1920562-F1B9-4F2D-8BC1-39C693B2F429}"/>
               </a:ext>
             </a:extLst>
           </p:cNvPr>
@@ -8635,7 +8635,7 @@
           <p:cNvPr id="24" name="">
             <a:extLst xmlns:a="http://schemas.openxmlformats.org/drawingml/2006/main">
               <a:ext uri="{FF2B5EF4-FFF2-40B4-BE49-F238E27FC236}">
-                <a16:creationId xmlns:a16="http://schemas.microsoft.com/office/drawing/2014/main" id="{9E6925D2-77FB-4727-9888-6CC37D847345}"/>
+                <a16:creationId xmlns:a16="http://schemas.microsoft.com/office/drawing/2014/main" id="{99991223-878C-4D9A-8C9C-5735B6A939CC}"/>
               </a:ext>
             </a:extLst>
           </p:cNvPr>
@@ -8668,7 +8668,7 @@
           <p:cNvPr id="25" name="">
             <a:extLst xmlns:a="http://schemas.openxmlformats.org/drawingml/2006/main">
               <a:ext uri="{FF2B5EF4-FFF2-40B4-BE49-F238E27FC236}">
-                <a16:creationId xmlns:a16="http://schemas.microsoft.com/office/drawing/2014/main" id="{C507EA45-466F-4401-8D3C-19E028715F12}"/>
+                <a16:creationId xmlns:a16="http://schemas.microsoft.com/office/drawing/2014/main" id="{B282FA65-30C7-42E9-87EC-13CFC9090460}"/>
               </a:ext>
             </a:extLst>
           </p:cNvPr>
@@ -8718,7 +8718,7 @@
           <p:cNvPr id="26" name="">
             <a:extLst xmlns:a="http://schemas.openxmlformats.org/drawingml/2006/main">
               <a:ext uri="{FF2B5EF4-FFF2-40B4-BE49-F238E27FC236}">
-                <a16:creationId xmlns:a16="http://schemas.microsoft.com/office/drawing/2014/main" id="{27D1580F-B304-4BDD-A9C6-DCE373D0FBED}"/>
+                <a16:creationId xmlns:a16="http://schemas.microsoft.com/office/drawing/2014/main" id="{D6BD45EF-F663-4EE7-A78A-B32F29C6D855}"/>
               </a:ext>
             </a:extLst>
           </p:cNvPr>
@@ -8751,7 +8751,7 @@
           <p:cNvPr id="27" name="">
             <a:extLst xmlns:a="http://schemas.openxmlformats.org/drawingml/2006/main">
               <a:ext uri="{FF2B5EF4-FFF2-40B4-BE49-F238E27FC236}">
-                <a16:creationId xmlns:a16="http://schemas.microsoft.com/office/drawing/2014/main" id="{9BDE0887-E554-4137-86C5-FA9CCF210817}"/>
+                <a16:creationId xmlns:a16="http://schemas.microsoft.com/office/drawing/2014/main" id="{1199AFE7-1E92-44AC-9D25-008A5791D026}"/>
               </a:ext>
             </a:extLst>
           </p:cNvPr>
@@ -8801,7 +8801,7 @@
           <p:cNvPr id="28" name="">
             <a:extLst xmlns:a="http://schemas.openxmlformats.org/drawingml/2006/main">
               <a:ext uri="{FF2B5EF4-FFF2-40B4-BE49-F238E27FC236}">
-                <a16:creationId xmlns:a16="http://schemas.microsoft.com/office/drawing/2014/main" id="{EEF9A4D1-C658-416B-845C-8B01334FBE91}"/>
+                <a16:creationId xmlns:a16="http://schemas.microsoft.com/office/drawing/2014/main" id="{8EF0A984-745B-46ED-A856-07785667D03C}"/>
               </a:ext>
             </a:extLst>
           </p:cNvPr>
@@ -8834,7 +8834,7 @@
           <p:cNvPr id="29" name="">
             <a:extLst xmlns:a="http://schemas.openxmlformats.org/drawingml/2006/main">
               <a:ext uri="{FF2B5EF4-FFF2-40B4-BE49-F238E27FC236}">
-                <a16:creationId xmlns:a16="http://schemas.microsoft.com/office/drawing/2014/main" id="{648D6CB7-A058-4836-921D-84DD1209FF33}"/>
+                <a16:creationId xmlns:a16="http://schemas.microsoft.com/office/drawing/2014/main" id="{02AC8938-5AAF-47A4-9AAC-68F70B778406}"/>
               </a:ext>
             </a:extLst>
           </p:cNvPr>
@@ -8884,7 +8884,7 @@
           <p:cNvPr id="30" name="">
             <a:extLst xmlns:a="http://schemas.openxmlformats.org/drawingml/2006/main">
               <a:ext uri="{FF2B5EF4-FFF2-40B4-BE49-F238E27FC236}">
-                <a16:creationId xmlns:a16="http://schemas.microsoft.com/office/drawing/2014/main" id="{5063BF3D-DD46-461D-89C6-383F70B4DF5B}"/>
+                <a16:creationId xmlns:a16="http://schemas.microsoft.com/office/drawing/2014/main" id="{5848721D-984B-4CDF-8027-6672D191685D}"/>
               </a:ext>
             </a:extLst>
           </p:cNvPr>
@@ -8917,7 +8917,7 @@
           <p:cNvPr id="31" name="">
             <a:extLst xmlns:a="http://schemas.openxmlformats.org/drawingml/2006/main">
               <a:ext uri="{FF2B5EF4-FFF2-40B4-BE49-F238E27FC236}">
-                <a16:creationId xmlns:a16="http://schemas.microsoft.com/office/drawing/2014/main" id="{F4AF0A05-A22E-43AA-932D-DAEFDBB08281}"/>
+                <a16:creationId xmlns:a16="http://schemas.microsoft.com/office/drawing/2014/main" id="{62402BE5-1A92-496C-9DAB-821F2D68FD30}"/>
               </a:ext>
             </a:extLst>
           </p:cNvPr>
@@ -8967,7 +8967,7 @@
           <p:cNvPr id="32" name="">
             <a:extLst xmlns:a="http://schemas.openxmlformats.org/drawingml/2006/main">
               <a:ext uri="{FF2B5EF4-FFF2-40B4-BE49-F238E27FC236}">
-                <a16:creationId xmlns:a16="http://schemas.microsoft.com/office/drawing/2014/main" id="{C0A6CE3A-BA60-4B8B-AB7C-AB75FB810CCF}"/>
+                <a16:creationId xmlns:a16="http://schemas.microsoft.com/office/drawing/2014/main" id="{56DB2EF7-C352-4590-A2EB-09456E1DEBC5}"/>
               </a:ext>
             </a:extLst>
           </p:cNvPr>
@@ -9000,7 +9000,7 @@
           <p:cNvPr id="33" name="">
             <a:extLst xmlns:a="http://schemas.openxmlformats.org/drawingml/2006/main">
               <a:ext uri="{FF2B5EF4-FFF2-40B4-BE49-F238E27FC236}">
-                <a16:creationId xmlns:a16="http://schemas.microsoft.com/office/drawing/2014/main" id="{E33CDCD4-FF23-493D-97F4-F639E89339C7}"/>
+                <a16:creationId xmlns:a16="http://schemas.microsoft.com/office/drawing/2014/main" id="{9A0ED56D-7ABA-40D9-B912-D2FCAC297BAE}"/>
               </a:ext>
             </a:extLst>
           </p:cNvPr>
@@ -9050,7 +9050,7 @@
           <p:cNvPr id="34" name="">
             <a:extLst xmlns:a="http://schemas.openxmlformats.org/drawingml/2006/main">
               <a:ext uri="{FF2B5EF4-FFF2-40B4-BE49-F238E27FC236}">
-                <a16:creationId xmlns:a16="http://schemas.microsoft.com/office/drawing/2014/main" id="{2A2A4007-3E2C-4164-A532-10918E7696B2}"/>
+                <a16:creationId xmlns:a16="http://schemas.microsoft.com/office/drawing/2014/main" id="{2D847589-0544-4441-AABF-F40BF657D476}"/>
               </a:ext>
             </a:extLst>
           </p:cNvPr>
@@ -9083,7 +9083,7 @@
           <p:cNvPr id="35" name="">
             <a:extLst xmlns:a="http://schemas.openxmlformats.org/drawingml/2006/main">
               <a:ext uri="{FF2B5EF4-FFF2-40B4-BE49-F238E27FC236}">
-                <a16:creationId xmlns:a16="http://schemas.microsoft.com/office/drawing/2014/main" id="{993C10AE-8240-4E9C-883F-6C3E1F1D6C84}"/>
+                <a16:creationId xmlns:a16="http://schemas.microsoft.com/office/drawing/2014/main" id="{2858A941-7755-4EA6-AEDE-089F10E2AFAC}"/>
               </a:ext>
             </a:extLst>
           </p:cNvPr>
@@ -9133,7 +9133,7 @@
           <p:cNvPr id="36" name="">
             <a:extLst xmlns:a="http://schemas.openxmlformats.org/drawingml/2006/main">
               <a:ext uri="{FF2B5EF4-FFF2-40B4-BE49-F238E27FC236}">
-                <a16:creationId xmlns:a16="http://schemas.microsoft.com/office/drawing/2014/main" id="{819C79CC-D4B1-4923-82B1-D7EF1C817024}"/>
+                <a16:creationId xmlns:a16="http://schemas.microsoft.com/office/drawing/2014/main" id="{3FBA01CD-80D3-407F-BD2D-70F396C0D533}"/>
               </a:ext>
             </a:extLst>
           </p:cNvPr>
@@ -9166,7 +9166,7 @@
           <p:cNvPr id="37" name="">
             <a:extLst xmlns:a="http://schemas.openxmlformats.org/drawingml/2006/main">
               <a:ext uri="{FF2B5EF4-FFF2-40B4-BE49-F238E27FC236}">
-                <a16:creationId xmlns:a16="http://schemas.microsoft.com/office/drawing/2014/main" id="{406FE0D1-BFF2-4624-99E9-1482A84E84EA}"/>
+                <a16:creationId xmlns:a16="http://schemas.microsoft.com/office/drawing/2014/main" id="{E90F0204-50B0-442A-8E96-7BFE7C929345}"/>
               </a:ext>
             </a:extLst>
           </p:cNvPr>
@@ -9216,7 +9216,7 @@
           <p:cNvPr id="38" name="">
             <a:extLst xmlns:a="http://schemas.openxmlformats.org/drawingml/2006/main">
               <a:ext uri="{FF2B5EF4-FFF2-40B4-BE49-F238E27FC236}">
-                <a16:creationId xmlns:a16="http://schemas.microsoft.com/office/drawing/2014/main" id="{D53EF18B-4033-4B2D-A52C-7DE1CB0E53E5}"/>
+                <a16:creationId xmlns:a16="http://schemas.microsoft.com/office/drawing/2014/main" id="{AC569130-9E9C-4DCC-AFAF-2A62820AEB60}"/>
               </a:ext>
             </a:extLst>
           </p:cNvPr>
@@ -9249,7 +9249,7 @@
           <p:cNvPr id="39" name="">
             <a:extLst xmlns:a="http://schemas.openxmlformats.org/drawingml/2006/main">
               <a:ext uri="{FF2B5EF4-FFF2-40B4-BE49-F238E27FC236}">
-                <a16:creationId xmlns:a16="http://schemas.microsoft.com/office/drawing/2014/main" id="{06131C9A-DD03-4C1D-863C-3A723158FE23}"/>
+                <a16:creationId xmlns:a16="http://schemas.microsoft.com/office/drawing/2014/main" id="{18C0A877-546B-45E7-924A-EB2246282428}"/>
               </a:ext>
             </a:extLst>
           </p:cNvPr>
@@ -9299,7 +9299,7 @@
           <p:cNvPr id="40" name="">
             <a:extLst xmlns:a="http://schemas.openxmlformats.org/drawingml/2006/main">
               <a:ext uri="{FF2B5EF4-FFF2-40B4-BE49-F238E27FC236}">
-                <a16:creationId xmlns:a16="http://schemas.microsoft.com/office/drawing/2014/main" id="{41538AC1-B077-4B0E-BAA6-96A8702A279E}"/>
+                <a16:creationId xmlns:a16="http://schemas.microsoft.com/office/drawing/2014/main" id="{11A8025E-A4C3-4BEA-9773-BE49CFCEAE45}"/>
               </a:ext>
             </a:extLst>
           </p:cNvPr>
@@ -9332,7 +9332,7 @@
           <p:cNvPr id="41" name="">
             <a:extLst xmlns:a="http://schemas.openxmlformats.org/drawingml/2006/main">
               <a:ext uri="{FF2B5EF4-FFF2-40B4-BE49-F238E27FC236}">
-                <a16:creationId xmlns:a16="http://schemas.microsoft.com/office/drawing/2014/main" id="{4A830B68-C47F-48F9-88AF-8430D236D0A2}"/>
+                <a16:creationId xmlns:a16="http://schemas.microsoft.com/office/drawing/2014/main" id="{B6587229-E3A5-4820-8B73-B164C04004CE}"/>
               </a:ext>
             </a:extLst>
           </p:cNvPr>
@@ -9382,7 +9382,7 @@
           <p:cNvPr id="42" name="">
             <a:extLst xmlns:a="http://schemas.openxmlformats.org/drawingml/2006/main">
               <a:ext uri="{FF2B5EF4-FFF2-40B4-BE49-F238E27FC236}">
-                <a16:creationId xmlns:a16="http://schemas.microsoft.com/office/drawing/2014/main" id="{7171DF22-512E-4574-B888-5EED7BE09A27}"/>
+                <a16:creationId xmlns:a16="http://schemas.microsoft.com/office/drawing/2014/main" id="{9ECE93E2-FAB6-4BAB-A355-58BE148B6ABF}"/>
               </a:ext>
             </a:extLst>
           </p:cNvPr>
@@ -9415,7 +9415,7 @@
           <p:cNvPr id="43" name="">
             <a:extLst xmlns:a="http://schemas.openxmlformats.org/drawingml/2006/main">
               <a:ext uri="{FF2B5EF4-FFF2-40B4-BE49-F238E27FC236}">
-                <a16:creationId xmlns:a16="http://schemas.microsoft.com/office/drawing/2014/main" id="{F388A5CD-0AEA-480C-B581-3CE92FF227FE}"/>
+                <a16:creationId xmlns:a16="http://schemas.microsoft.com/office/drawing/2014/main" id="{955EA221-C1B3-45D1-B2E4-D5D85185A152}"/>
               </a:ext>
             </a:extLst>
           </p:cNvPr>
@@ -9463,7 +9463,7 @@
     </p:spTree>
     <p:extLst>
       <p:ext uri="{BB962C8B-B14F-4D97-AF65-F5344CB8AC3E}">
-        <p14:creationId xmlns:p14="http://schemas.microsoft.com/office/powerpoint/2010/main" val="793180689"/>
+        <p14:creationId xmlns:p14="http://schemas.microsoft.com/office/powerpoint/2010/main" val="1642166191"/>
       </p:ext>
     </p:extLst>
   </p:cSld>
@@ -9494,7 +9494,7 @@
           <p:cNvPr id="19" name="">
             <a:extLst xmlns:a="http://schemas.openxmlformats.org/drawingml/2006/main">
               <a:ext uri="{FF2B5EF4-FFF2-40B4-BE49-F238E27FC236}">
-                <a16:creationId xmlns:a16="http://schemas.microsoft.com/office/drawing/2014/main" id="{05ECD4DC-481D-4BBB-A6FE-BC762BC507A4}"/>
+                <a16:creationId xmlns:a16="http://schemas.microsoft.com/office/drawing/2014/main" id="{56D24AF5-8267-4EA7-90BB-0413D2800CBC}"/>
               </a:ext>
             </a:extLst>
           </p:cNvPr>
@@ -9544,7 +9544,7 @@
           <p:cNvPr id="2" name="">
             <a:extLst xmlns:a="http://schemas.openxmlformats.org/drawingml/2006/main">
               <a:ext uri="{FF2B5EF4-FFF2-40B4-BE49-F238E27FC236}">
-                <a16:creationId xmlns:a16="http://schemas.microsoft.com/office/drawing/2014/main" id="{650A384C-A8D2-4679-B9E5-52416CEFA6BA}"/>
+                <a16:creationId xmlns:a16="http://schemas.microsoft.com/office/drawing/2014/main" id="{9E8094AE-CBC3-455F-8818-3CBCECC05C49}"/>
               </a:ext>
             </a:extLst>
           </p:cNvPr>
@@ -9594,7 +9594,7 @@
           <p:cNvPr id="3" name="">
             <a:extLst xmlns:a="http://schemas.openxmlformats.org/drawingml/2006/main">
               <a:ext uri="{FF2B5EF4-FFF2-40B4-BE49-F238E27FC236}">
-                <a16:creationId xmlns:a16="http://schemas.microsoft.com/office/drawing/2014/main" id="{CFAA1126-26C0-4421-9F7F-307F6164CCE3}"/>
+                <a16:creationId xmlns:a16="http://schemas.microsoft.com/office/drawing/2014/main" id="{074400AC-1986-4101-8A32-624C50E1604E}"/>
               </a:ext>
             </a:extLst>
           </p:cNvPr>
@@ -9625,7 +9625,7 @@
           <p:cNvPr id="4" name="">
             <a:extLst xmlns:a="http://schemas.openxmlformats.org/drawingml/2006/main">
               <a:ext uri="{FF2B5EF4-FFF2-40B4-BE49-F238E27FC236}">
-                <a16:creationId xmlns:a16="http://schemas.microsoft.com/office/drawing/2014/main" id="{0EE05E07-669C-4BCD-82E2-D44A07E77621}"/>
+                <a16:creationId xmlns:a16="http://schemas.microsoft.com/office/drawing/2014/main" id="{6A39AB5B-1325-48AE-A947-C3292B087BCC}"/>
               </a:ext>
             </a:extLst>
           </p:cNvPr>
@@ -9675,7 +9675,7 @@
           <p:cNvPr id="5" name="">
             <a:extLst xmlns:a="http://schemas.openxmlformats.org/drawingml/2006/main">
               <a:ext uri="{FF2B5EF4-FFF2-40B4-BE49-F238E27FC236}">
-                <a16:creationId xmlns:a16="http://schemas.microsoft.com/office/drawing/2014/main" id="{A5F21AAB-F3A8-4799-AB90-E7C034CC6CBA}"/>
+                <a16:creationId xmlns:a16="http://schemas.microsoft.com/office/drawing/2014/main" id="{29CFC69E-9A73-4F59-959B-FB6F6E293D10}"/>
               </a:ext>
             </a:extLst>
           </p:cNvPr>
@@ -9725,7 +9725,7 @@
           <p:cNvPr id="6" name="">
             <a:extLst xmlns:a="http://schemas.openxmlformats.org/drawingml/2006/main">
               <a:ext uri="{FF2B5EF4-FFF2-40B4-BE49-F238E27FC236}">
-                <a16:creationId xmlns:a16="http://schemas.microsoft.com/office/drawing/2014/main" id="{7CF4DD10-B626-4DDA-9C94-D02076117A0E}"/>
+                <a16:creationId xmlns:a16="http://schemas.microsoft.com/office/drawing/2014/main" id="{01FAD7DA-5B02-430E-9D8E-9E2C4A6DE84C}"/>
               </a:ext>
             </a:extLst>
           </p:cNvPr>
@@ -9775,7 +9775,7 @@
           <p:cNvPr id="7" name="">
             <a:extLst xmlns:a="http://schemas.openxmlformats.org/drawingml/2006/main">
               <a:ext uri="{FF2B5EF4-FFF2-40B4-BE49-F238E27FC236}">
-                <a16:creationId xmlns:a16="http://schemas.microsoft.com/office/drawing/2014/main" id="{C8CD7D4A-9B0D-4383-815C-29DBEE0FEE05}"/>
+                <a16:creationId xmlns:a16="http://schemas.microsoft.com/office/drawing/2014/main" id="{BA6AC92C-A673-46F0-AB1A-793AE6A72676}"/>
               </a:ext>
             </a:extLst>
           </p:cNvPr>
@@ -9825,7 +9825,7 @@
           <p:cNvPr id="8" name="">
             <a:extLst xmlns:a="http://schemas.openxmlformats.org/drawingml/2006/main">
               <a:ext uri="{FF2B5EF4-FFF2-40B4-BE49-F238E27FC236}">
-                <a16:creationId xmlns:a16="http://schemas.microsoft.com/office/drawing/2014/main" id="{1C9524CF-658E-4055-BD9F-F24ADC3FFDD4}"/>
+                <a16:creationId xmlns:a16="http://schemas.microsoft.com/office/drawing/2014/main" id="{815749F9-C536-401F-9C83-584AF8C27D3D}"/>
               </a:ext>
             </a:extLst>
           </p:cNvPr>
@@ -9860,7 +9860,7 @@
           <p:cNvPr id="9" name="">
             <a:extLst xmlns:a="http://schemas.openxmlformats.org/drawingml/2006/main">
               <a:ext uri="{FF2B5EF4-FFF2-40B4-BE49-F238E27FC236}">
-                <a16:creationId xmlns:a16="http://schemas.microsoft.com/office/drawing/2014/main" id="{08EB1E3E-AE79-432E-985B-F6475584EA40}"/>
+                <a16:creationId xmlns:a16="http://schemas.microsoft.com/office/drawing/2014/main" id="{089F4EA7-EFF5-43D8-B449-85AF64370578}"/>
               </a:ext>
             </a:extLst>
           </p:cNvPr>
@@ -9910,7 +9910,7 @@
           <p:cNvPr id="10" name="">
             <a:extLst xmlns:a="http://schemas.openxmlformats.org/drawingml/2006/main">
               <a:ext uri="{FF2B5EF4-FFF2-40B4-BE49-F238E27FC236}">
-                <a16:creationId xmlns:a16="http://schemas.microsoft.com/office/drawing/2014/main" id="{B71C5746-2C23-4519-97AF-EAD7097923DB}"/>
+                <a16:creationId xmlns:a16="http://schemas.microsoft.com/office/drawing/2014/main" id="{2CCFFAFC-D88E-4F91-AFC3-EB80D7CAFC22}"/>
               </a:ext>
             </a:extLst>
           </p:cNvPr>
@@ -9941,7 +9941,7 @@
           <p:cNvPr id="11" name="">
             <a:extLst xmlns:a="http://schemas.openxmlformats.org/drawingml/2006/main">
               <a:ext uri="{FF2B5EF4-FFF2-40B4-BE49-F238E27FC236}">
-                <a16:creationId xmlns:a16="http://schemas.microsoft.com/office/drawing/2014/main" id="{F8139CE0-BAE8-401A-B257-35815A78FC9E}"/>
+                <a16:creationId xmlns:a16="http://schemas.microsoft.com/office/drawing/2014/main" id="{381A760B-BAD3-46D7-BF60-CC939E596681}"/>
               </a:ext>
             </a:extLst>
           </p:cNvPr>
@@ -9991,7 +9991,7 @@
           <p:cNvPr id="12" name="">
             <a:extLst xmlns:a="http://schemas.openxmlformats.org/drawingml/2006/main">
               <a:ext uri="{FF2B5EF4-FFF2-40B4-BE49-F238E27FC236}">
-                <a16:creationId xmlns:a16="http://schemas.microsoft.com/office/drawing/2014/main" id="{81B1AEE6-3A37-40C0-B0A8-CD205A19FFEE}"/>
+                <a16:creationId xmlns:a16="http://schemas.microsoft.com/office/drawing/2014/main" id="{5B1ED7A8-6C4D-49DF-921A-0507B00D64CE}"/>
               </a:ext>
             </a:extLst>
           </p:cNvPr>
@@ -10041,7 +10041,7 @@
           <p:cNvPr id="13" name="">
             <a:extLst xmlns:a="http://schemas.openxmlformats.org/drawingml/2006/main">
               <a:ext uri="{FF2B5EF4-FFF2-40B4-BE49-F238E27FC236}">
-                <a16:creationId xmlns:a16="http://schemas.microsoft.com/office/drawing/2014/main" id="{4F5C4BE8-D23C-4BA7-844D-D341210FBFDD}"/>
+                <a16:creationId xmlns:a16="http://schemas.microsoft.com/office/drawing/2014/main" id="{0E511746-0354-4C16-B8F2-F60D19AD41E6}"/>
               </a:ext>
             </a:extLst>
           </p:cNvPr>
@@ -10072,7 +10072,7 @@
           <p:cNvPr id="14" name="">
             <a:extLst xmlns:a="http://schemas.openxmlformats.org/drawingml/2006/main">
               <a:ext uri="{FF2B5EF4-FFF2-40B4-BE49-F238E27FC236}">
-                <a16:creationId xmlns:a16="http://schemas.microsoft.com/office/drawing/2014/main" id="{C09C129B-D324-4F3A-8DB8-281C9E0CB705}"/>
+                <a16:creationId xmlns:a16="http://schemas.microsoft.com/office/drawing/2014/main" id="{C1AA5621-C711-41B0-A537-822A8F96C743}"/>
               </a:ext>
             </a:extLst>
           </p:cNvPr>
@@ -10122,7 +10122,7 @@
           <p:cNvPr id="15" name="">
             <a:extLst xmlns:a="http://schemas.openxmlformats.org/drawingml/2006/main">
               <a:ext uri="{FF2B5EF4-FFF2-40B4-BE49-F238E27FC236}">
-                <a16:creationId xmlns:a16="http://schemas.microsoft.com/office/drawing/2014/main" id="{9DAF67EF-E0DF-4307-ACF0-277A3EB34611}"/>
+                <a16:creationId xmlns:a16="http://schemas.microsoft.com/office/drawing/2014/main" id="{294E5718-2A8E-49E8-B6B4-05943E24589B}"/>
               </a:ext>
             </a:extLst>
           </p:cNvPr>
@@ -10172,7 +10172,7 @@
           <p:cNvPr id="16" name="">
             <a:extLst xmlns:a="http://schemas.openxmlformats.org/drawingml/2006/main">
               <a:ext uri="{FF2B5EF4-FFF2-40B4-BE49-F238E27FC236}">
-                <a16:creationId xmlns:a16="http://schemas.microsoft.com/office/drawing/2014/main" id="{8AF25515-BFC0-4526-A83C-1A927D935490}"/>
+                <a16:creationId xmlns:a16="http://schemas.microsoft.com/office/drawing/2014/main" id="{DB3D0F7A-A7D5-4942-8AE9-D96AE8ACD7BF}"/>
               </a:ext>
             </a:extLst>
           </p:cNvPr>
@@ -10203,7 +10203,7 @@
           <p:cNvPr id="17" name="">
             <a:extLst xmlns:a="http://schemas.openxmlformats.org/drawingml/2006/main">
               <a:ext uri="{FF2B5EF4-FFF2-40B4-BE49-F238E27FC236}">
-                <a16:creationId xmlns:a16="http://schemas.microsoft.com/office/drawing/2014/main" id="{59F2AD72-7421-476F-A811-4BC39B91DB1E}"/>
+                <a16:creationId xmlns:a16="http://schemas.microsoft.com/office/drawing/2014/main" id="{01EE240C-87D7-48C6-BFE9-AB7DAE4B11D6}"/>
               </a:ext>
             </a:extLst>
           </p:cNvPr>
@@ -10253,7 +10253,7 @@
           <p:cNvPr id="18" name="">
             <a:extLst xmlns:a="http://schemas.openxmlformats.org/drawingml/2006/main">
               <a:ext uri="{FF2B5EF4-FFF2-40B4-BE49-F238E27FC236}">
-                <a16:creationId xmlns:a16="http://schemas.microsoft.com/office/drawing/2014/main" id="{DA3FD34A-53D8-4670-9D3E-D01E09F1910D}"/>
+                <a16:creationId xmlns:a16="http://schemas.microsoft.com/office/drawing/2014/main" id="{1DEC9DAF-DB58-46FA-A0FA-0FD6DE4A13C7}"/>
               </a:ext>
             </a:extLst>
           </p:cNvPr>
@@ -10301,7 +10301,7 @@
     </p:spTree>
     <p:extLst>
       <p:ext uri="{BB962C8B-B14F-4D97-AF65-F5344CB8AC3E}">
-        <p14:creationId xmlns:p14="http://schemas.microsoft.com/office/powerpoint/2010/main" val="564129574"/>
+        <p14:creationId xmlns:p14="http://schemas.microsoft.com/office/powerpoint/2010/main" val="104867806"/>
       </p:ext>
     </p:extLst>
   </p:cSld>

</xml_diff>